<commit_message>
Historias de Usuario en excel
</commit_message>
<xml_diff>
--- a/PresentacionProyecto(JoyeriaEdén).pptx
+++ b/PresentacionProyecto(JoyeriaEdén).pptx
@@ -123,7 +123,7 @@
 <file path=ppt/revisionInfo.xml><?xml version="1.0" encoding="utf-8"?>
 <p1510:revInfo xmlns:a="http://schemas.openxmlformats.org/drawingml/2006/main" xmlns:r="http://schemas.openxmlformats.org/officeDocument/2006/relationships" xmlns:p1510="http://schemas.microsoft.com/office/powerpoint/2015/10/main">
   <p1510:revLst>
-    <p1510:client id="{C36AD4B4-4AE5-4515-A822-AD52DCC308D4}" v="13" dt="2026-08-20T20:26:21.200"/>
+    <p1510:client id="{C36AD4B4-4AE5-4515-A822-AD52DCC308D4}" v="14" dt="2026-08-21T13:12:36.565"/>
   </p1510:revLst>
 </p1510:revInfo>
 </file>
@@ -133,7 +133,7 @@
   <pc:docChgLst>
     <pc:chgData name="Ederson Muñoz Caicedo" userId="cea34d606acf50ec" providerId="LiveId" clId="{B48C790C-5850-4E98-8EA5-02E2828FD09E}"/>
     <pc:docChg chg="undo custSel addSld delSld modSld sldOrd">
-      <pc:chgData name="Ederson Muñoz Caicedo" userId="cea34d606acf50ec" providerId="LiveId" clId="{B48C790C-5850-4E98-8EA5-02E2828FD09E}" dt="2026-08-20T20:35:09.325" v="1880" actId="1076"/>
+      <pc:chgData name="Ederson Muñoz Caicedo" userId="cea34d606acf50ec" providerId="LiveId" clId="{B48C790C-5850-4E98-8EA5-02E2828FD09E}" dt="2026-08-21T13:12:36.564" v="1886"/>
       <pc:docMkLst>
         <pc:docMk/>
       </pc:docMkLst>
@@ -363,7 +363,7 @@
         </pc:sldMkLst>
       </pc:sldChg>
       <pc:sldChg chg="addSp delSp modSp new mod ord">
-        <pc:chgData name="Ederson Muñoz Caicedo" userId="cea34d606acf50ec" providerId="LiveId" clId="{B48C790C-5850-4E98-8EA5-02E2828FD09E}" dt="2026-08-20T20:35:09.325" v="1880" actId="1076"/>
+        <pc:chgData name="Ederson Muñoz Caicedo" userId="cea34d606acf50ec" providerId="LiveId" clId="{B48C790C-5850-4E98-8EA5-02E2828FD09E}" dt="2026-08-21T13:12:36.564" v="1886"/>
         <pc:sldMkLst>
           <pc:docMk/>
           <pc:sldMk cId="3414823298" sldId="264"/>
@@ -377,7 +377,7 @@
           </ac:spMkLst>
         </pc:spChg>
         <pc:spChg chg="add del mod">
-          <ac:chgData name="Ederson Muñoz Caicedo" userId="cea34d606acf50ec" providerId="LiveId" clId="{B48C790C-5850-4E98-8EA5-02E2828FD09E}" dt="2026-08-20T20:35:02.749" v="1879" actId="1076"/>
+          <ac:chgData name="Ederson Muñoz Caicedo" userId="cea34d606acf50ec" providerId="LiveId" clId="{B48C790C-5850-4E98-8EA5-02E2828FD09E}" dt="2026-08-21T13:12:36.564" v="1886"/>
           <ac:spMkLst>
             <pc:docMk/>
             <pc:sldMk cId="3414823298" sldId="264"/>
@@ -502,7 +502,7 @@
           <a:p>
             <a:fld id="{4C471756-1CA1-1F4A-9860-0C578ADBAF67}" type="datetimeFigureOut">
               <a:rPr lang="es-ES" smtClean="0"/>
-              <a:t>20/08/2026</a:t>
+              <a:t>21/08/2026</a:t>
             </a:fld>
             <a:endParaRPr lang="es-ES"/>
           </a:p>
@@ -1000,7 +1000,7 @@
           <a:p>
             <a:fld id="{88110A85-4D4F-F042-95AD-B4092DC44AD3}" type="datetimeFigureOut">
               <a:rPr lang="es-ES" smtClean="0"/>
-              <a:t>20/08/2026</a:t>
+              <a:t>21/08/2026</a:t>
             </a:fld>
             <a:endParaRPr lang="es-ES"/>
           </a:p>
@@ -1198,7 +1198,7 @@
           <a:p>
             <a:fld id="{88110A85-4D4F-F042-95AD-B4092DC44AD3}" type="datetimeFigureOut">
               <a:rPr lang="es-ES" smtClean="0"/>
-              <a:t>20/08/2026</a:t>
+              <a:t>21/08/2026</a:t>
             </a:fld>
             <a:endParaRPr lang="es-ES"/>
           </a:p>
@@ -1406,7 +1406,7 @@
           <a:p>
             <a:fld id="{88110A85-4D4F-F042-95AD-B4092DC44AD3}" type="datetimeFigureOut">
               <a:rPr lang="es-ES" smtClean="0"/>
-              <a:t>20/08/2026</a:t>
+              <a:t>21/08/2026</a:t>
             </a:fld>
             <a:endParaRPr lang="es-ES"/>
           </a:p>
@@ -1604,7 +1604,7 @@
           <a:p>
             <a:fld id="{88110A85-4D4F-F042-95AD-B4092DC44AD3}" type="datetimeFigureOut">
               <a:rPr lang="es-ES" smtClean="0"/>
-              <a:t>20/08/2026</a:t>
+              <a:t>21/08/2026</a:t>
             </a:fld>
             <a:endParaRPr lang="es-ES"/>
           </a:p>
@@ -1879,7 +1879,7 @@
           <a:p>
             <a:fld id="{88110A85-4D4F-F042-95AD-B4092DC44AD3}" type="datetimeFigureOut">
               <a:rPr lang="es-ES" smtClean="0"/>
-              <a:t>20/08/2026</a:t>
+              <a:t>21/08/2026</a:t>
             </a:fld>
             <a:endParaRPr lang="es-ES"/>
           </a:p>
@@ -2144,7 +2144,7 @@
           <a:p>
             <a:fld id="{88110A85-4D4F-F042-95AD-B4092DC44AD3}" type="datetimeFigureOut">
               <a:rPr lang="es-ES" smtClean="0"/>
-              <a:t>20/08/2026</a:t>
+              <a:t>21/08/2026</a:t>
             </a:fld>
             <a:endParaRPr lang="es-ES"/>
           </a:p>
@@ -2556,7 +2556,7 @@
           <a:p>
             <a:fld id="{88110A85-4D4F-F042-95AD-B4092DC44AD3}" type="datetimeFigureOut">
               <a:rPr lang="es-ES" smtClean="0"/>
-              <a:t>20/08/2026</a:t>
+              <a:t>21/08/2026</a:t>
             </a:fld>
             <a:endParaRPr lang="es-ES"/>
           </a:p>
@@ -2697,7 +2697,7 @@
           <a:p>
             <a:fld id="{88110A85-4D4F-F042-95AD-B4092DC44AD3}" type="datetimeFigureOut">
               <a:rPr lang="es-ES" smtClean="0"/>
-              <a:t>20/08/2026</a:t>
+              <a:t>21/08/2026</a:t>
             </a:fld>
             <a:endParaRPr lang="es-ES"/>
           </a:p>
@@ -2810,7 +2810,7 @@
           <a:p>
             <a:fld id="{88110A85-4D4F-F042-95AD-B4092DC44AD3}" type="datetimeFigureOut">
               <a:rPr lang="es-ES" smtClean="0"/>
-              <a:t>20/08/2026</a:t>
+              <a:t>21/08/2026</a:t>
             </a:fld>
             <a:endParaRPr lang="es-ES"/>
           </a:p>
@@ -3121,7 +3121,7 @@
           <a:p>
             <a:fld id="{88110A85-4D4F-F042-95AD-B4092DC44AD3}" type="datetimeFigureOut">
               <a:rPr lang="es-ES" smtClean="0"/>
-              <a:t>20/08/2026</a:t>
+              <a:t>21/08/2026</a:t>
             </a:fld>
             <a:endParaRPr lang="es-ES"/>
           </a:p>
@@ -3409,7 +3409,7 @@
           <a:p>
             <a:fld id="{88110A85-4D4F-F042-95AD-B4092DC44AD3}" type="datetimeFigureOut">
               <a:rPr lang="es-ES" smtClean="0"/>
-              <a:t>20/08/2026</a:t>
+              <a:t>21/08/2026</a:t>
             </a:fld>
             <a:endParaRPr lang="es-ES"/>
           </a:p>
@@ -3650,7 +3650,7 @@
           <a:p>
             <a:fld id="{88110A85-4D4F-F042-95AD-B4092DC44AD3}" type="datetimeFigureOut">
               <a:rPr lang="es-ES" smtClean="0"/>
-              <a:t>20/08/2026</a:t>
+              <a:t>21/08/2026</a:t>
             </a:fld>
             <a:endParaRPr lang="es-ES"/>
           </a:p>
@@ -6432,14 +6432,14 @@
             <a:pPr algn="l"/>
             <a:r>
               <a:rPr lang="es-CO" dirty="0"/>
-              <a:t>Luis Miguel Solis Bolaños : Desarrollador</a:t>
+              <a:t>Luis Fernando Becerra Fernández : Analista y Diseñador</a:t>
             </a:r>
           </a:p>
           <a:p>
             <a:pPr algn="l"/>
             <a:r>
               <a:rPr lang="es-CO" dirty="0"/>
-              <a:t>Luis Fernando Becerra Fernández : Analista y Diseñador </a:t>
+              <a:t>Luis Miguel Solis Bolaños : Desarrollador </a:t>
             </a:r>
           </a:p>
           <a:p>

</xml_diff>

<commit_message>
Agrega avance de React
</commit_message>
<xml_diff>
--- a/PresentacionProyecto(JoyeriaEdén).pptx
+++ b/PresentacionProyecto(JoyeriaEdén).pptx
@@ -5,7 +5,7 @@
     <p:sldMasterId id="2147483648" r:id="rId1"/>
   </p:sldMasterIdLst>
   <p:notesMasterIdLst>
-    <p:notesMasterId r:id="rId8"/>
+    <p:notesMasterId r:id="rId13"/>
   </p:notesMasterIdLst>
   <p:sldIdLst>
     <p:sldId id="257" r:id="rId2"/>
@@ -13,7 +13,12 @@
     <p:sldId id="258" r:id="rId4"/>
     <p:sldId id="261" r:id="rId5"/>
     <p:sldId id="264" r:id="rId6"/>
-    <p:sldId id="260" r:id="rId7"/>
+    <p:sldId id="265" r:id="rId7"/>
+    <p:sldId id="266" r:id="rId8"/>
+    <p:sldId id="267" r:id="rId9"/>
+    <p:sldId id="268" r:id="rId10"/>
+    <p:sldId id="269" r:id="rId11"/>
+    <p:sldId id="260" r:id="rId12"/>
   </p:sldIdLst>
   <p:sldSz cx="12192000" cy="6858000"/>
   <p:notesSz cx="6858000" cy="9144000"/>
@@ -123,7 +128,7 @@
 <file path=ppt/revisionInfo.xml><?xml version="1.0" encoding="utf-8"?>
 <p1510:revInfo xmlns:a="http://schemas.openxmlformats.org/drawingml/2006/main" xmlns:r="http://schemas.openxmlformats.org/officeDocument/2006/relationships" xmlns:p1510="http://schemas.microsoft.com/office/powerpoint/2015/10/main">
   <p1510:revLst>
-    <p1510:client id="{C36AD4B4-4AE5-4515-A822-AD52DCC308D4}" v="14" dt="2026-08-21T13:12:36.565"/>
+    <p1510:client id="{C36AD4B4-4AE5-4515-A822-AD52DCC308D4}" v="24" dt="2026-09-10T17:37:37.577"/>
   </p1510:revLst>
 </p1510:revInfo>
 </file>
@@ -133,7 +138,7 @@
   <pc:docChgLst>
     <pc:chgData name="Ederson Muñoz Caicedo" userId="cea34d606acf50ec" providerId="LiveId" clId="{B48C790C-5850-4E98-8EA5-02E2828FD09E}"/>
     <pc:docChg chg="undo custSel addSld delSld modSld sldOrd">
-      <pc:chgData name="Ederson Muñoz Caicedo" userId="cea34d606acf50ec" providerId="LiveId" clId="{B48C790C-5850-4E98-8EA5-02E2828FD09E}" dt="2026-08-21T13:12:36.564" v="1886"/>
+      <pc:chgData name="Ederson Muñoz Caicedo" userId="cea34d606acf50ec" providerId="LiveId" clId="{B48C790C-5850-4E98-8EA5-02E2828FD09E}" dt="2026-09-10T17:38:59.311" v="2422" actId="20577"/>
       <pc:docMkLst>
         <pc:docMk/>
       </pc:docMkLst>
@@ -199,13 +204,6 @@
           </ac:picMkLst>
         </pc:picChg>
       </pc:sldChg>
-      <pc:sldChg chg="del">
-        <pc:chgData name="Ederson Muñoz Caicedo" userId="cea34d606acf50ec" providerId="LiveId" clId="{B48C790C-5850-4E98-8EA5-02E2828FD09E}" dt="2026-08-20T16:01:14.088" v="0" actId="47"/>
-        <pc:sldMkLst>
-          <pc:docMk/>
-          <pc:sldMk cId="2401465010" sldId="259"/>
-        </pc:sldMkLst>
-      </pc:sldChg>
       <pc:sldChg chg="addSp modSp mod setBg">
         <pc:chgData name="Ederson Muñoz Caicedo" userId="cea34d606acf50ec" providerId="LiveId" clId="{B48C790C-5850-4E98-8EA5-02E2828FD09E}" dt="2026-08-20T20:34:42.115" v="1877" actId="1076"/>
         <pc:sldMkLst>
@@ -253,29 +251,6 @@
           </ac:picMkLst>
         </pc:picChg>
       </pc:sldChg>
-      <pc:sldChg chg="modSp del mod">
-        <pc:chgData name="Ederson Muñoz Caicedo" userId="cea34d606acf50ec" providerId="LiveId" clId="{B48C790C-5850-4E98-8EA5-02E2828FD09E}" dt="2026-08-20T20:23:54.404" v="1738" actId="2696"/>
-        <pc:sldMkLst>
-          <pc:docMk/>
-          <pc:sldMk cId="667464790" sldId="262"/>
-        </pc:sldMkLst>
-        <pc:spChg chg="mod">
-          <ac:chgData name="Ederson Muñoz Caicedo" userId="cea34d606acf50ec" providerId="LiveId" clId="{B48C790C-5850-4E98-8EA5-02E2828FD09E}" dt="2026-08-20T16:01:42.985" v="32" actId="20577"/>
-          <ac:spMkLst>
-            <pc:docMk/>
-            <pc:sldMk cId="667464790" sldId="262"/>
-            <ac:spMk id="2" creationId="{70408CDB-AF99-23DA-5783-49C6FB105570}"/>
-          </ac:spMkLst>
-        </pc:spChg>
-        <pc:spChg chg="mod">
-          <ac:chgData name="Ederson Muñoz Caicedo" userId="cea34d606acf50ec" providerId="LiveId" clId="{B48C790C-5850-4E98-8EA5-02E2828FD09E}" dt="2026-08-20T16:22:16.883" v="1277" actId="20577"/>
-          <ac:spMkLst>
-            <pc:docMk/>
-            <pc:sldMk cId="667464790" sldId="262"/>
-            <ac:spMk id="3" creationId="{CB8B7842-095A-A953-5B16-4B0D2F9E9E7E}"/>
-          </ac:spMkLst>
-        </pc:spChg>
-      </pc:sldChg>
       <pc:sldChg chg="addSp delSp modSp new mod ord setBg">
         <pc:chgData name="Ederson Muñoz Caicedo" userId="cea34d606acf50ec" providerId="LiveId" clId="{B48C790C-5850-4E98-8EA5-02E2828FD09E}" dt="2026-08-20T20:32:07.142" v="1865" actId="26606"/>
         <pc:sldMkLst>
@@ -314,38 +289,6 @@
             <ac:spMk id="11" creationId="{D4974D33-8DC5-464E-8C6D-BE58F0669C17}"/>
           </ac:spMkLst>
         </pc:spChg>
-        <pc:spChg chg="add del">
-          <ac:chgData name="Ederson Muñoz Caicedo" userId="cea34d606acf50ec" providerId="LiveId" clId="{B48C790C-5850-4E98-8EA5-02E2828FD09E}" dt="2026-08-20T20:32:07.142" v="1865" actId="26606"/>
-          <ac:spMkLst>
-            <pc:docMk/>
-            <pc:sldMk cId="187346082" sldId="263"/>
-            <ac:spMk id="16" creationId="{637B2035-1FCB-439A-B421-095E136C7E07}"/>
-          </ac:spMkLst>
-        </pc:spChg>
-        <pc:spChg chg="add del">
-          <ac:chgData name="Ederson Muñoz Caicedo" userId="cea34d606acf50ec" providerId="LiveId" clId="{B48C790C-5850-4E98-8EA5-02E2828FD09E}" dt="2026-08-20T20:32:07.142" v="1865" actId="26606"/>
-          <ac:spMkLst>
-            <pc:docMk/>
-            <pc:sldMk cId="187346082" sldId="263"/>
-            <ac:spMk id="18" creationId="{B39A1F5A-E57E-4178-8F57-A18DC747E5E1}"/>
-          </ac:spMkLst>
-        </pc:spChg>
-        <pc:spChg chg="add del">
-          <ac:chgData name="Ederson Muñoz Caicedo" userId="cea34d606acf50ec" providerId="LiveId" clId="{B48C790C-5850-4E98-8EA5-02E2828FD09E}" dt="2026-08-20T20:32:07.142" v="1865" actId="26606"/>
-          <ac:spMkLst>
-            <pc:docMk/>
-            <pc:sldMk cId="187346082" sldId="263"/>
-            <ac:spMk id="20" creationId="{CF93DC6C-1BFD-4414-BF23-471C8831CA04}"/>
-          </ac:spMkLst>
-        </pc:spChg>
-        <pc:spChg chg="add del">
-          <ac:chgData name="Ederson Muñoz Caicedo" userId="cea34d606acf50ec" providerId="LiveId" clId="{B48C790C-5850-4E98-8EA5-02E2828FD09E}" dt="2026-08-20T20:32:07.142" v="1865" actId="26606"/>
-          <ac:spMkLst>
-            <pc:docMk/>
-            <pc:sldMk cId="187346082" sldId="263"/>
-            <ac:spMk id="22" creationId="{001928A5-13A8-4372-8A77-BCAAE5553E6F}"/>
-          </ac:spMkLst>
-        </pc:spChg>
         <pc:picChg chg="add mod">
           <ac:chgData name="Ederson Muñoz Caicedo" userId="cea34d606acf50ec" providerId="LiveId" clId="{B48C790C-5850-4E98-8EA5-02E2828FD09E}" dt="2026-08-20T20:32:07.142" v="1865" actId="26606"/>
           <ac:picMkLst>
@@ -354,13 +297,6 @@
             <ac:picMk id="4" creationId="{28A86B9C-632D-4770-7F9E-422528B34C2B}"/>
           </ac:picMkLst>
         </pc:picChg>
-      </pc:sldChg>
-      <pc:sldChg chg="del">
-        <pc:chgData name="Ederson Muñoz Caicedo" userId="cea34d606acf50ec" providerId="LiveId" clId="{B48C790C-5850-4E98-8EA5-02E2828FD09E}" dt="2026-08-20T16:01:17.617" v="3" actId="47"/>
-        <pc:sldMkLst>
-          <pc:docMk/>
-          <pc:sldMk cId="3770042391" sldId="263"/>
-        </pc:sldMkLst>
       </pc:sldChg>
       <pc:sldChg chg="addSp delSp modSp new mod ord">
         <pc:chgData name="Ederson Muñoz Caicedo" userId="cea34d606acf50ec" providerId="LiveId" clId="{B48C790C-5850-4E98-8EA5-02E2828FD09E}" dt="2026-08-21T13:12:36.564" v="1886"/>
@@ -384,36 +320,257 @@
             <ac:spMk id="3" creationId="{D408D165-87A7-39DA-0711-639538958A95}"/>
           </ac:spMkLst>
         </pc:spChg>
-        <pc:spChg chg="add del mod">
-          <ac:chgData name="Ederson Muñoz Caicedo" userId="cea34d606acf50ec" providerId="LiveId" clId="{B48C790C-5850-4E98-8EA5-02E2828FD09E}" dt="2026-08-20T20:14:18.190" v="1681"/>
+      </pc:sldChg>
+      <pc:sldChg chg="addSp delSp modSp new mod setBg">
+        <pc:chgData name="Ederson Muñoz Caicedo" userId="cea34d606acf50ec" providerId="LiveId" clId="{B48C790C-5850-4E98-8EA5-02E2828FD09E}" dt="2026-09-10T17:20:32.979" v="2132" actId="26606"/>
+        <pc:sldMkLst>
+          <pc:docMk/>
+          <pc:sldMk cId="826275547" sldId="265"/>
+        </pc:sldMkLst>
+        <pc:spChg chg="mod">
+          <ac:chgData name="Ederson Muñoz Caicedo" userId="cea34d606acf50ec" providerId="LiveId" clId="{B48C790C-5850-4E98-8EA5-02E2828FD09E}" dt="2026-09-10T17:20:32.979" v="2132" actId="26606"/>
           <ac:spMkLst>
             <pc:docMk/>
-            <pc:sldMk cId="3414823298" sldId="264"/>
-            <ac:spMk id="4" creationId="{C14759D9-B26B-57FE-70DF-E859E0F5397B}"/>
+            <pc:sldMk cId="826275547" sldId="265"/>
+            <ac:spMk id="2" creationId="{9AA6266C-F8A6-1CF0-FA1A-4491A335A97E}"/>
           </ac:spMkLst>
         </pc:spChg>
-        <pc:spChg chg="add del mod">
-          <ac:chgData name="Ederson Muñoz Caicedo" userId="cea34d606acf50ec" providerId="LiveId" clId="{B48C790C-5850-4E98-8EA5-02E2828FD09E}" dt="2026-08-20T20:14:48.174" v="1687"/>
+        <pc:spChg chg="mod">
+          <ac:chgData name="Ederson Muñoz Caicedo" userId="cea34d606acf50ec" providerId="LiveId" clId="{B48C790C-5850-4E98-8EA5-02E2828FD09E}" dt="2026-09-10T17:20:32.979" v="2132" actId="26606"/>
           <ac:spMkLst>
             <pc:docMk/>
-            <pc:sldMk cId="3414823298" sldId="264"/>
-            <ac:spMk id="5" creationId="{36B8E86F-F4D2-860B-68EB-4ACFDBAF4CF7}"/>
+            <pc:sldMk cId="826275547" sldId="265"/>
+            <ac:spMk id="3" creationId="{CCCC1410-C5AC-F531-D2B6-B189DCBFF5CF}"/>
           </ac:spMkLst>
         </pc:spChg>
+        <pc:spChg chg="add del">
+          <ac:chgData name="Ederson Muñoz Caicedo" userId="cea34d606acf50ec" providerId="LiveId" clId="{B48C790C-5850-4E98-8EA5-02E2828FD09E}" dt="2026-09-10T17:20:32.970" v="2131" actId="26606"/>
+          <ac:spMkLst>
+            <pc:docMk/>
+            <pc:sldMk cId="826275547" sldId="265"/>
+            <ac:spMk id="16" creationId="{E817EB35-4D5C-493B-8459-98C99FD1667F}"/>
+          </ac:spMkLst>
+        </pc:spChg>
+        <pc:spChg chg="add del">
+          <ac:chgData name="Ederson Muñoz Caicedo" userId="cea34d606acf50ec" providerId="LiveId" clId="{B48C790C-5850-4E98-8EA5-02E2828FD09E}" dt="2026-09-10T17:20:32.970" v="2131" actId="26606"/>
+          <ac:spMkLst>
+            <pc:docMk/>
+            <pc:sldMk cId="826275547" sldId="265"/>
+            <ac:spMk id="18" creationId="{70BEB1E7-2F88-40BC-B73D-42E5B6F80BFC}"/>
+          </ac:spMkLst>
+        </pc:spChg>
+        <pc:spChg chg="add">
+          <ac:chgData name="Ederson Muñoz Caicedo" userId="cea34d606acf50ec" providerId="LiveId" clId="{B48C790C-5850-4E98-8EA5-02E2828FD09E}" dt="2026-09-10T17:20:32.979" v="2132" actId="26606"/>
+          <ac:spMkLst>
+            <pc:docMk/>
+            <pc:sldMk cId="826275547" sldId="265"/>
+            <ac:spMk id="20" creationId="{1EE285D5-8110-4AE6-AF36-F83E457E175B}"/>
+          </ac:spMkLst>
+        </pc:spChg>
+        <pc:spChg chg="add">
+          <ac:chgData name="Ederson Muñoz Caicedo" userId="cea34d606acf50ec" providerId="LiveId" clId="{B48C790C-5850-4E98-8EA5-02E2828FD09E}" dt="2026-09-10T17:20:32.979" v="2132" actId="26606"/>
+          <ac:spMkLst>
+            <pc:docMk/>
+            <pc:sldMk cId="826275547" sldId="265"/>
+            <ac:spMk id="21" creationId="{3FCFB1DE-0B7E-48CC-BA90-B2AB0889F9D6}"/>
+          </ac:spMkLst>
+        </pc:spChg>
+        <pc:picChg chg="add mod">
+          <ac:chgData name="Ederson Muñoz Caicedo" userId="cea34d606acf50ec" providerId="LiveId" clId="{B48C790C-5850-4E98-8EA5-02E2828FD09E}" dt="2026-09-10T17:20:32.979" v="2132" actId="26606"/>
+          <ac:picMkLst>
+            <pc:docMk/>
+            <pc:sldMk cId="826275547" sldId="265"/>
+            <ac:picMk id="5" creationId="{BAD00D11-5FFB-2499-3688-4483045621B1}"/>
+          </ac:picMkLst>
+        </pc:picChg>
+        <pc:picChg chg="add mod ord">
+          <ac:chgData name="Ederson Muñoz Caicedo" userId="cea34d606acf50ec" providerId="LiveId" clId="{B48C790C-5850-4E98-8EA5-02E2828FD09E}" dt="2026-09-10T17:20:32.979" v="2132" actId="26606"/>
+          <ac:picMkLst>
+            <pc:docMk/>
+            <pc:sldMk cId="826275547" sldId="265"/>
+            <ac:picMk id="7" creationId="{E4C839D6-DEDD-8C98-6B9E-3985065E79C1}"/>
+          </ac:picMkLst>
+        </pc:picChg>
+        <pc:picChg chg="add mod">
+          <ac:chgData name="Ederson Muñoz Caicedo" userId="cea34d606acf50ec" providerId="LiveId" clId="{B48C790C-5850-4E98-8EA5-02E2828FD09E}" dt="2026-09-10T17:20:32.979" v="2132" actId="26606"/>
+          <ac:picMkLst>
+            <pc:docMk/>
+            <pc:sldMk cId="826275547" sldId="265"/>
+            <ac:picMk id="9" creationId="{8D7750A8-836F-0032-CCAA-A156E5E52B94}"/>
+          </ac:picMkLst>
+        </pc:picChg>
+        <pc:picChg chg="add mod ord">
+          <ac:chgData name="Ederson Muñoz Caicedo" userId="cea34d606acf50ec" providerId="LiveId" clId="{B48C790C-5850-4E98-8EA5-02E2828FD09E}" dt="2026-09-10T17:20:32.979" v="2132" actId="26606"/>
+          <ac:picMkLst>
+            <pc:docMk/>
+            <pc:sldMk cId="826275547" sldId="265"/>
+            <ac:picMk id="11" creationId="{0FCC98F0-A95B-B4F6-D053-5649E1CFC868}"/>
+          </ac:picMkLst>
+        </pc:picChg>
       </pc:sldChg>
-      <pc:sldChg chg="del">
-        <pc:chgData name="Ederson Muñoz Caicedo" userId="cea34d606acf50ec" providerId="LiveId" clId="{B48C790C-5850-4E98-8EA5-02E2828FD09E}" dt="2026-08-20T16:01:16.711" v="2" actId="47"/>
+      <pc:sldChg chg="addSp delSp modSp new mod setBg">
+        <pc:chgData name="Ederson Muñoz Caicedo" userId="cea34d606acf50ec" providerId="LiveId" clId="{B48C790C-5850-4E98-8EA5-02E2828FD09E}" dt="2026-09-10T17:32:41.952" v="2331" actId="20577"/>
         <pc:sldMkLst>
           <pc:docMk/>
-          <pc:sldMk cId="4038712202" sldId="264"/>
+          <pc:sldMk cId="2526403144" sldId="266"/>
         </pc:sldMkLst>
+        <pc:spChg chg="mod">
+          <ac:chgData name="Ederson Muñoz Caicedo" userId="cea34d606acf50ec" providerId="LiveId" clId="{B48C790C-5850-4E98-8EA5-02E2828FD09E}" dt="2026-09-10T17:32:41.952" v="2331" actId="20577"/>
+          <ac:spMkLst>
+            <pc:docMk/>
+            <pc:sldMk cId="2526403144" sldId="266"/>
+            <ac:spMk id="2" creationId="{5171C725-3FFD-40F3-44F5-366FFC3DC230}"/>
+          </ac:spMkLst>
+        </pc:spChg>
+        <pc:spChg chg="mod">
+          <ac:chgData name="Ederson Muñoz Caicedo" userId="cea34d606acf50ec" providerId="LiveId" clId="{B48C790C-5850-4E98-8EA5-02E2828FD09E}" dt="2026-09-10T17:27:36.409" v="2256" actId="1076"/>
+          <ac:spMkLst>
+            <pc:docMk/>
+            <pc:sldMk cId="2526403144" sldId="266"/>
+            <ac:spMk id="3" creationId="{149B451A-2BB9-BE65-2ED3-37DE6E252E9B}"/>
+          </ac:spMkLst>
+        </pc:spChg>
+        <pc:spChg chg="add">
+          <ac:chgData name="Ederson Muñoz Caicedo" userId="cea34d606acf50ec" providerId="LiveId" clId="{B48C790C-5850-4E98-8EA5-02E2828FD09E}" dt="2026-09-10T17:23:35.846" v="2211" actId="26606"/>
+          <ac:spMkLst>
+            <pc:docMk/>
+            <pc:sldMk cId="2526403144" sldId="266"/>
+            <ac:spMk id="10" creationId="{2B97F24A-32CE-4C1C-A50D-3016B394DCFB}"/>
+          </ac:spMkLst>
+        </pc:spChg>
+        <pc:spChg chg="add">
+          <ac:chgData name="Ederson Muñoz Caicedo" userId="cea34d606acf50ec" providerId="LiveId" clId="{B48C790C-5850-4E98-8EA5-02E2828FD09E}" dt="2026-09-10T17:23:35.846" v="2211" actId="26606"/>
+          <ac:spMkLst>
+            <pc:docMk/>
+            <pc:sldMk cId="2526403144" sldId="266"/>
+            <ac:spMk id="12" creationId="{CD8B4F24-440B-49E9-B85D-733523DC064B}"/>
+          </ac:spMkLst>
+        </pc:spChg>
+        <pc:graphicFrameChg chg="add del mod modGraphic">
+          <ac:chgData name="Ederson Muñoz Caicedo" userId="cea34d606acf50ec" providerId="LiveId" clId="{B48C790C-5850-4E98-8EA5-02E2828FD09E}" dt="2026-09-10T17:22:55.628" v="2203" actId="478"/>
+          <ac:graphicFrameMkLst>
+            <pc:docMk/>
+            <pc:sldMk cId="2526403144" sldId="266"/>
+            <ac:graphicFrameMk id="4" creationId="{65B6C132-5229-3BCB-28A0-D54C65429E2F}"/>
+          </ac:graphicFrameMkLst>
+        </pc:graphicFrameChg>
+        <pc:graphicFrameChg chg="add mod modGraphic">
+          <ac:chgData name="Ederson Muñoz Caicedo" userId="cea34d606acf50ec" providerId="LiveId" clId="{B48C790C-5850-4E98-8EA5-02E2828FD09E}" dt="2026-09-10T17:28:29.873" v="2269" actId="20577"/>
+          <ac:graphicFrameMkLst>
+            <pc:docMk/>
+            <pc:sldMk cId="2526403144" sldId="266"/>
+            <ac:graphicFrameMk id="5" creationId="{2A564A36-1681-540F-9631-91D47839C67E}"/>
+          </ac:graphicFrameMkLst>
+        </pc:graphicFrameChg>
       </pc:sldChg>
-      <pc:sldChg chg="del">
-        <pc:chgData name="Ederson Muñoz Caicedo" userId="cea34d606acf50ec" providerId="LiveId" clId="{B48C790C-5850-4E98-8EA5-02E2828FD09E}" dt="2026-08-20T16:01:15.206" v="1" actId="47"/>
+      <pc:sldChg chg="addSp delSp modSp new mod">
+        <pc:chgData name="Ederson Muñoz Caicedo" userId="cea34d606acf50ec" providerId="LiveId" clId="{B48C790C-5850-4E98-8EA5-02E2828FD09E}" dt="2026-09-10T17:32:54.861" v="2333"/>
         <pc:sldMkLst>
           <pc:docMk/>
-          <pc:sldMk cId="1751262195" sldId="265"/>
+          <pc:sldMk cId="550869811" sldId="267"/>
         </pc:sldMkLst>
+        <pc:spChg chg="mod">
+          <ac:chgData name="Ederson Muñoz Caicedo" userId="cea34d606acf50ec" providerId="LiveId" clId="{B48C790C-5850-4E98-8EA5-02E2828FD09E}" dt="2026-09-10T17:32:54.861" v="2333"/>
+          <ac:spMkLst>
+            <pc:docMk/>
+            <pc:sldMk cId="550869811" sldId="267"/>
+            <ac:spMk id="2" creationId="{1A930660-ADF4-E0AA-9354-CC0B520E8CF9}"/>
+          </ac:spMkLst>
+        </pc:spChg>
+        <pc:spChg chg="del">
+          <ac:chgData name="Ederson Muñoz Caicedo" userId="cea34d606acf50ec" providerId="LiveId" clId="{B48C790C-5850-4E98-8EA5-02E2828FD09E}" dt="2026-09-10T17:26:22.905" v="2243" actId="478"/>
+          <ac:spMkLst>
+            <pc:docMk/>
+            <pc:sldMk cId="550869811" sldId="267"/>
+            <ac:spMk id="3" creationId="{38864E5A-701F-B3A4-3AF1-DDF318612B0B}"/>
+          </ac:spMkLst>
+        </pc:spChg>
+        <pc:graphicFrameChg chg="add mod modGraphic">
+          <ac:chgData name="Ederson Muñoz Caicedo" userId="cea34d606acf50ec" providerId="LiveId" clId="{B48C790C-5850-4E98-8EA5-02E2828FD09E}" dt="2026-09-10T17:31:28.980" v="2298" actId="14734"/>
+          <ac:graphicFrameMkLst>
+            <pc:docMk/>
+            <pc:sldMk cId="550869811" sldId="267"/>
+            <ac:graphicFrameMk id="4" creationId="{A043AA19-C06A-B37B-ED12-D1909A3A593A}"/>
+          </ac:graphicFrameMkLst>
+        </pc:graphicFrameChg>
+      </pc:sldChg>
+      <pc:sldChg chg="addSp delSp modSp new mod setBg">
+        <pc:chgData name="Ederson Muñoz Caicedo" userId="cea34d606acf50ec" providerId="LiveId" clId="{B48C790C-5850-4E98-8EA5-02E2828FD09E}" dt="2026-09-10T17:34:50.859" v="2364" actId="1076"/>
+        <pc:sldMkLst>
+          <pc:docMk/>
+          <pc:sldMk cId="4091595647" sldId="268"/>
+        </pc:sldMkLst>
+        <pc:spChg chg="mod">
+          <ac:chgData name="Ederson Muñoz Caicedo" userId="cea34d606acf50ec" providerId="LiveId" clId="{B48C790C-5850-4E98-8EA5-02E2828FD09E}" dt="2026-09-10T17:34:45.706" v="2362" actId="26606"/>
+          <ac:spMkLst>
+            <pc:docMk/>
+            <pc:sldMk cId="4091595647" sldId="268"/>
+            <ac:spMk id="2" creationId="{E7DD6360-CD78-BB3F-4627-A7ED5C9D30C5}"/>
+          </ac:spMkLst>
+        </pc:spChg>
+        <pc:spChg chg="del">
+          <ac:chgData name="Ederson Muñoz Caicedo" userId="cea34d606acf50ec" providerId="LiveId" clId="{B48C790C-5850-4E98-8EA5-02E2828FD09E}" dt="2026-09-10T17:34:30.843" v="2335" actId="478"/>
+          <ac:spMkLst>
+            <pc:docMk/>
+            <pc:sldMk cId="4091595647" sldId="268"/>
+            <ac:spMk id="3" creationId="{190BB1E3-A8D7-15EF-E739-1DBCDC679C33}"/>
+          </ac:spMkLst>
+        </pc:spChg>
+        <pc:spChg chg="add">
+          <ac:chgData name="Ederson Muñoz Caicedo" userId="cea34d606acf50ec" providerId="LiveId" clId="{B48C790C-5850-4E98-8EA5-02E2828FD09E}" dt="2026-09-10T17:34:45.706" v="2362" actId="26606"/>
+          <ac:spMkLst>
+            <pc:docMk/>
+            <pc:sldMk cId="4091595647" sldId="268"/>
+            <ac:spMk id="10" creationId="{D4771268-CB57-404A-9271-370EB28F6090}"/>
+          </ac:spMkLst>
+        </pc:spChg>
+        <pc:picChg chg="add mod">
+          <ac:chgData name="Ederson Muñoz Caicedo" userId="cea34d606acf50ec" providerId="LiveId" clId="{B48C790C-5850-4E98-8EA5-02E2828FD09E}" dt="2026-09-10T17:34:50.859" v="2364" actId="1076"/>
+          <ac:picMkLst>
+            <pc:docMk/>
+            <pc:sldMk cId="4091595647" sldId="268"/>
+            <ac:picMk id="5" creationId="{D78A79AA-76CE-432E-6683-A2B53B046F4A}"/>
+          </ac:picMkLst>
+        </pc:picChg>
+      </pc:sldChg>
+      <pc:sldChg chg="addSp delSp modSp new mod">
+        <pc:chgData name="Ederson Muñoz Caicedo" userId="cea34d606acf50ec" providerId="LiveId" clId="{B48C790C-5850-4E98-8EA5-02E2828FD09E}" dt="2026-09-10T17:38:59.311" v="2422" actId="20577"/>
+        <pc:sldMkLst>
+          <pc:docMk/>
+          <pc:sldMk cId="1614665995" sldId="269"/>
+        </pc:sldMkLst>
+        <pc:spChg chg="mod">
+          <ac:chgData name="Ederson Muñoz Caicedo" userId="cea34d606acf50ec" providerId="LiveId" clId="{B48C790C-5850-4E98-8EA5-02E2828FD09E}" dt="2026-09-10T17:38:59.311" v="2422" actId="20577"/>
+          <ac:spMkLst>
+            <pc:docMk/>
+            <pc:sldMk cId="1614665995" sldId="269"/>
+            <ac:spMk id="2" creationId="{47F4D19A-E051-9D04-70BD-6D80589EF9F6}"/>
+          </ac:spMkLst>
+        </pc:spChg>
+        <pc:spChg chg="del">
+          <ac:chgData name="Ederson Muñoz Caicedo" userId="cea34d606acf50ec" providerId="LiveId" clId="{B48C790C-5850-4E98-8EA5-02E2828FD09E}" dt="2026-09-10T17:37:26.631" v="2391" actId="478"/>
+          <ac:spMkLst>
+            <pc:docMk/>
+            <pc:sldMk cId="1614665995" sldId="269"/>
+            <ac:spMk id="3" creationId="{AEAF9477-D937-D55C-4339-D581A5BC4233}"/>
+          </ac:spMkLst>
+        </pc:spChg>
+        <pc:graphicFrameChg chg="add del mod modGraphic">
+          <ac:chgData name="Ederson Muñoz Caicedo" userId="cea34d606acf50ec" providerId="LiveId" clId="{B48C790C-5850-4E98-8EA5-02E2828FD09E}" dt="2026-09-10T17:38:13.082" v="2399" actId="478"/>
+          <ac:graphicFrameMkLst>
+            <pc:docMk/>
+            <pc:sldMk cId="1614665995" sldId="269"/>
+            <ac:graphicFrameMk id="4" creationId="{2D571F02-EF50-E11A-78CD-A3BE9499CD16}"/>
+          </ac:graphicFrameMkLst>
+        </pc:graphicFrameChg>
+        <pc:picChg chg="add mod">
+          <ac:chgData name="Ederson Muñoz Caicedo" userId="cea34d606acf50ec" providerId="LiveId" clId="{B48C790C-5850-4E98-8EA5-02E2828FD09E}" dt="2026-09-10T17:38:54.824" v="2420" actId="1076"/>
+          <ac:picMkLst>
+            <pc:docMk/>
+            <pc:sldMk cId="1614665995" sldId="269"/>
+            <ac:picMk id="6" creationId="{8C9A5D71-5489-60DC-F69B-D13B16BB3F75}"/>
+          </ac:picMkLst>
+        </pc:picChg>
       </pc:sldChg>
     </pc:docChg>
   </pc:docChgLst>
@@ -502,7 +659,7 @@
           <a:p>
             <a:fld id="{4C471756-1CA1-1F4A-9860-0C578ADBAF67}" type="datetimeFigureOut">
               <a:rPr lang="es-ES" smtClean="0"/>
-              <a:t>21/08/2026</a:t>
+              <a:t>10/09/2026</a:t>
             </a:fld>
             <a:endParaRPr lang="es-ES"/>
           </a:p>
@@ -797,6 +954,13 @@
           </p:nvPr>
         </p:nvSpPr>
         <p:spPr/>
+        <p:txBody>
+          <a:bodyPr/>
+          <a:lstStyle/>
+          <a:p>
+            <a:endParaRPr lang="es-CO"/>
+          </a:p>
+        </p:txBody>
       </p:sp>
       <p:sp>
         <p:nvSpPr>
@@ -834,7 +998,7 @@
           <a:p>
             <a:fld id="{10BC4798-3E81-C549-995C-77B1554192F5}" type="slidenum">
               <a:rPr lang="es-ES" smtClean="0"/>
-              <a:t>6</a:t>
+              <a:t>11</a:t>
             </a:fld>
             <a:endParaRPr lang="es-ES"/>
           </a:p>
@@ -1000,7 +1164,7 @@
           <a:p>
             <a:fld id="{88110A85-4D4F-F042-95AD-B4092DC44AD3}" type="datetimeFigureOut">
               <a:rPr lang="es-ES" smtClean="0"/>
-              <a:t>21/08/2026</a:t>
+              <a:t>10/09/2026</a:t>
             </a:fld>
             <a:endParaRPr lang="es-ES"/>
           </a:p>
@@ -1198,7 +1362,7 @@
           <a:p>
             <a:fld id="{88110A85-4D4F-F042-95AD-B4092DC44AD3}" type="datetimeFigureOut">
               <a:rPr lang="es-ES" smtClean="0"/>
-              <a:t>21/08/2026</a:t>
+              <a:t>10/09/2026</a:t>
             </a:fld>
             <a:endParaRPr lang="es-ES"/>
           </a:p>
@@ -1406,7 +1570,7 @@
           <a:p>
             <a:fld id="{88110A85-4D4F-F042-95AD-B4092DC44AD3}" type="datetimeFigureOut">
               <a:rPr lang="es-ES" smtClean="0"/>
-              <a:t>21/08/2026</a:t>
+              <a:t>10/09/2026</a:t>
             </a:fld>
             <a:endParaRPr lang="es-ES"/>
           </a:p>
@@ -1604,7 +1768,7 @@
           <a:p>
             <a:fld id="{88110A85-4D4F-F042-95AD-B4092DC44AD3}" type="datetimeFigureOut">
               <a:rPr lang="es-ES" smtClean="0"/>
-              <a:t>21/08/2026</a:t>
+              <a:t>10/09/2026</a:t>
             </a:fld>
             <a:endParaRPr lang="es-ES"/>
           </a:p>
@@ -1879,7 +2043,7 @@
           <a:p>
             <a:fld id="{88110A85-4D4F-F042-95AD-B4092DC44AD3}" type="datetimeFigureOut">
               <a:rPr lang="es-ES" smtClean="0"/>
-              <a:t>21/08/2026</a:t>
+              <a:t>10/09/2026</a:t>
             </a:fld>
             <a:endParaRPr lang="es-ES"/>
           </a:p>
@@ -2144,7 +2308,7 @@
           <a:p>
             <a:fld id="{88110A85-4D4F-F042-95AD-B4092DC44AD3}" type="datetimeFigureOut">
               <a:rPr lang="es-ES" smtClean="0"/>
-              <a:t>21/08/2026</a:t>
+              <a:t>10/09/2026</a:t>
             </a:fld>
             <a:endParaRPr lang="es-ES"/>
           </a:p>
@@ -2556,7 +2720,7 @@
           <a:p>
             <a:fld id="{88110A85-4D4F-F042-95AD-B4092DC44AD3}" type="datetimeFigureOut">
               <a:rPr lang="es-ES" smtClean="0"/>
-              <a:t>21/08/2026</a:t>
+              <a:t>10/09/2026</a:t>
             </a:fld>
             <a:endParaRPr lang="es-ES"/>
           </a:p>
@@ -2697,7 +2861,7 @@
           <a:p>
             <a:fld id="{88110A85-4D4F-F042-95AD-B4092DC44AD3}" type="datetimeFigureOut">
               <a:rPr lang="es-ES" smtClean="0"/>
-              <a:t>21/08/2026</a:t>
+              <a:t>10/09/2026</a:t>
             </a:fld>
             <a:endParaRPr lang="es-ES"/>
           </a:p>
@@ -2810,7 +2974,7 @@
           <a:p>
             <a:fld id="{88110A85-4D4F-F042-95AD-B4092DC44AD3}" type="datetimeFigureOut">
               <a:rPr lang="es-ES" smtClean="0"/>
-              <a:t>21/08/2026</a:t>
+              <a:t>10/09/2026</a:t>
             </a:fld>
             <a:endParaRPr lang="es-ES"/>
           </a:p>
@@ -3121,7 +3285,7 @@
           <a:p>
             <a:fld id="{88110A85-4D4F-F042-95AD-B4092DC44AD3}" type="datetimeFigureOut">
               <a:rPr lang="es-ES" smtClean="0"/>
-              <a:t>21/08/2026</a:t>
+              <a:t>10/09/2026</a:t>
             </a:fld>
             <a:endParaRPr lang="es-ES"/>
           </a:p>
@@ -3409,7 +3573,7 @@
           <a:p>
             <a:fld id="{88110A85-4D4F-F042-95AD-B4092DC44AD3}" type="datetimeFigureOut">
               <a:rPr lang="es-ES" smtClean="0"/>
-              <a:t>21/08/2026</a:t>
+              <a:t>10/09/2026</a:t>
             </a:fld>
             <a:endParaRPr lang="es-ES"/>
           </a:p>
@@ -3650,7 +3814,7 @@
           <a:p>
             <a:fld id="{88110A85-4D4F-F042-95AD-B4092DC44AD3}" type="datetimeFigureOut">
               <a:rPr lang="es-ES" smtClean="0"/>
-              <a:t>21/08/2026</a:t>
+              <a:t>10/09/2026</a:t>
             </a:fld>
             <a:endParaRPr lang="es-ES"/>
           </a:p>
@@ -4201,6 +4365,138 @@
 </p:sld>
 </file>
 
+<file path=ppt/slides/slide10.xml><?xml version="1.0" encoding="utf-8"?>
+<p:sld xmlns:a="http://schemas.openxmlformats.org/drawingml/2006/main" xmlns:r="http://schemas.openxmlformats.org/officeDocument/2006/relationships" xmlns:p="http://schemas.openxmlformats.org/presentationml/2006/main">
+  <p:cSld>
+    <p:spTree>
+      <p:nvGrpSpPr>
+        <p:cNvPr id="1" name=""/>
+        <p:cNvGrpSpPr/>
+        <p:nvPr/>
+      </p:nvGrpSpPr>
+      <p:grpSpPr>
+        <a:xfrm>
+          <a:off x="0" y="0"/>
+          <a:ext cx="0" cy="0"/>
+          <a:chOff x="0" y="0"/>
+          <a:chExt cx="0" cy="0"/>
+        </a:xfrm>
+      </p:grpSpPr>
+      <p:sp>
+        <p:nvSpPr>
+          <p:cNvPr id="2" name="Título 1">
+            <a:extLst>
+              <a:ext uri="{FF2B5EF4-FFF2-40B4-BE49-F238E27FC236}">
+                <a16:creationId xmlns:a16="http://schemas.microsoft.com/office/drawing/2014/main" id="{47F4D19A-E051-9D04-70BD-6D80589EF9F6}"/>
+              </a:ext>
+            </a:extLst>
+          </p:cNvPr>
+          <p:cNvSpPr>
+            <a:spLocks noGrp="1"/>
+          </p:cNvSpPr>
+          <p:nvPr>
+            <p:ph type="title"/>
+          </p:nvPr>
+        </p:nvSpPr>
+        <p:spPr/>
+        <p:txBody>
+          <a:bodyPr/>
+          <a:lstStyle/>
+          <a:p>
+            <a:r>
+              <a:rPr lang="es-CO" dirty="0"/>
+              <a:t>Alcance del proyecto de Implementación:</a:t>
+            </a:r>
+          </a:p>
+        </p:txBody>
+      </p:sp>
+      <p:pic>
+        <p:nvPicPr>
+          <p:cNvPr id="6" name="Imagen 5">
+            <a:extLst>
+              <a:ext uri="{FF2B5EF4-FFF2-40B4-BE49-F238E27FC236}">
+                <a16:creationId xmlns:a16="http://schemas.microsoft.com/office/drawing/2014/main" id="{8C9A5D71-5489-60DC-F69B-D13B16BB3F75}"/>
+              </a:ext>
+            </a:extLst>
+          </p:cNvPr>
+          <p:cNvPicPr>
+            <a:picLocks noChangeAspect="1"/>
+          </p:cNvPicPr>
+          <p:nvPr/>
+        </p:nvPicPr>
+        <p:blipFill>
+          <a:blip r:embed="rId2"/>
+          <a:stretch>
+            <a:fillRect/>
+          </a:stretch>
+        </p:blipFill>
+        <p:spPr>
+          <a:xfrm>
+            <a:off x="636234" y="1571611"/>
+            <a:ext cx="11148234" cy="4196729"/>
+          </a:xfrm>
+          <a:prstGeom prst="rect">
+            <a:avLst/>
+          </a:prstGeom>
+        </p:spPr>
+      </p:pic>
+    </p:spTree>
+    <p:extLst>
+      <p:ext uri="{BB962C8B-B14F-4D97-AF65-F5344CB8AC3E}">
+        <p14:creationId xmlns:p14="http://schemas.microsoft.com/office/powerpoint/2010/main" val="1614665995"/>
+      </p:ext>
+    </p:extLst>
+  </p:cSld>
+  <p:clrMapOvr>
+    <a:masterClrMapping/>
+  </p:clrMapOvr>
+</p:sld>
+</file>
+
+<file path=ppt/slides/slide11.xml><?xml version="1.0" encoding="utf-8"?>
+<p:sld xmlns:a="http://schemas.openxmlformats.org/drawingml/2006/main" xmlns:r="http://schemas.openxmlformats.org/officeDocument/2006/relationships" xmlns:p="http://schemas.openxmlformats.org/presentationml/2006/main">
+  <p:cSld>
+    <p:bg>
+      <p:bgPr>
+        <a:blipFill dpi="0" rotWithShape="1">
+          <a:blip r:embed="rId3">
+            <a:lum/>
+          </a:blip>
+          <a:srcRect/>
+          <a:stretch>
+            <a:fillRect/>
+          </a:stretch>
+        </a:blipFill>
+        <a:effectLst/>
+      </p:bgPr>
+    </p:bg>
+    <p:spTree>
+      <p:nvGrpSpPr>
+        <p:cNvPr id="1" name=""/>
+        <p:cNvGrpSpPr/>
+        <p:nvPr/>
+      </p:nvGrpSpPr>
+      <p:grpSpPr>
+        <a:xfrm>
+          <a:off x="0" y="0"/>
+          <a:ext cx="0" cy="0"/>
+          <a:chOff x="0" y="0"/>
+          <a:chExt cx="0" cy="0"/>
+        </a:xfrm>
+      </p:grpSpPr>
+    </p:spTree>
+    <p:extLst>
+      <p:ext uri="{BB962C8B-B14F-4D97-AF65-F5344CB8AC3E}">
+        <p14:creationId xmlns:p14="http://schemas.microsoft.com/office/powerpoint/2010/main" val="762635621"/>
+      </p:ext>
+    </p:extLst>
+  </p:cSld>
+  <p:clrMapOvr>
+    <a:masterClrMapping/>
+  </p:clrMapOvr>
+</p:sld>
+</file>
+
 <file path=ppt/slides/slide2.xml><?xml version="1.0" encoding="utf-8"?>
 <p:sld xmlns:a="http://schemas.openxmlformats.org/drawingml/2006/main" xmlns:r="http://schemas.openxmlformats.org/officeDocument/2006/relationships" xmlns:p="http://schemas.openxmlformats.org/presentationml/2006/main">
   <p:cSld>
@@ -6482,15 +6778,9 @@
   <p:cSld>
     <p:bg>
       <p:bgPr>
-        <a:blipFill dpi="0" rotWithShape="1">
-          <a:blip r:embed="rId3">
-            <a:lum/>
-          </a:blip>
-          <a:srcRect/>
-          <a:stretch>
-            <a:fillRect/>
-          </a:stretch>
-        </a:blipFill>
+        <a:solidFill>
+          <a:schemeClr val="bg1"/>
+        </a:solidFill>
         <a:effectLst/>
       </p:bgPr>
     </p:bg>
@@ -6508,10 +6798,3386 @@
           <a:chExt cx="0" cy="0"/>
         </a:xfrm>
       </p:grpSpPr>
+      <p:sp useBgFill="1">
+        <p:nvSpPr>
+          <p:cNvPr id="20" name="Rectangle 15">
+            <a:extLst>
+              <a:ext uri="{FF2B5EF4-FFF2-40B4-BE49-F238E27FC236}">
+                <a16:creationId xmlns:a16="http://schemas.microsoft.com/office/drawing/2014/main" id="{1EE285D5-8110-4AE6-AF36-F83E457E175B}"/>
+              </a:ext>
+              <a:ext uri="{C183D7F6-B498-43B3-948B-1728B52AA6E4}">
+                <adec:decorative xmlns:adec="http://schemas.microsoft.com/office/drawing/2017/decorative" val="1"/>
+              </a:ext>
+            </a:extLst>
+          </p:cNvPr>
+          <p:cNvSpPr>
+            <a:spLocks noGrp="1" noRot="1" noChangeAspect="1" noMove="1" noResize="1" noEditPoints="1" noAdjustHandles="1" noChangeArrowheads="1" noChangeShapeType="1" noTextEdit="1"/>
+          </p:cNvSpPr>
+          <p:nvPr>
+            <p:extLst>
+              <p:ext uri="{386F3935-93C4-4BCD-93E2-E3B085C9AB24}">
+                <p16:designElem xmlns:p16="http://schemas.microsoft.com/office/powerpoint/2015/main" val="1"/>
+              </p:ext>
+            </p:extLst>
+          </p:nvPr>
+        </p:nvSpPr>
+        <p:spPr>
+          <a:xfrm>
+            <a:off x="0" y="0"/>
+            <a:ext cx="12188952" cy="6858000"/>
+          </a:xfrm>
+          <a:prstGeom prst="rect">
+            <a:avLst/>
+          </a:prstGeom>
+          <a:ln>
+            <a:noFill/>
+          </a:ln>
+        </p:spPr>
+        <p:style>
+          <a:lnRef idx="2">
+            <a:schemeClr val="accent1">
+              <a:shade val="50000"/>
+            </a:schemeClr>
+          </a:lnRef>
+          <a:fillRef idx="1">
+            <a:schemeClr val="accent1"/>
+          </a:fillRef>
+          <a:effectRef idx="0">
+            <a:schemeClr val="accent1"/>
+          </a:effectRef>
+          <a:fontRef idx="minor">
+            <a:schemeClr val="lt1"/>
+          </a:fontRef>
+        </p:style>
+        <p:txBody>
+          <a:bodyPr rtlCol="0" anchor="ctr"/>
+          <a:lstStyle/>
+          <a:p>
+            <a:pPr algn="ctr"/>
+            <a:endParaRPr lang="en-US"/>
+          </a:p>
+        </p:txBody>
+      </p:sp>
+      <p:sp>
+        <p:nvSpPr>
+          <p:cNvPr id="2" name="Título 1">
+            <a:extLst>
+              <a:ext uri="{FF2B5EF4-FFF2-40B4-BE49-F238E27FC236}">
+                <a16:creationId xmlns:a16="http://schemas.microsoft.com/office/drawing/2014/main" id="{9AA6266C-F8A6-1CF0-FA1A-4491A335A97E}"/>
+              </a:ext>
+            </a:extLst>
+          </p:cNvPr>
+          <p:cNvSpPr>
+            <a:spLocks noGrp="1"/>
+          </p:cNvSpPr>
+          <p:nvPr>
+            <p:ph type="title"/>
+          </p:nvPr>
+        </p:nvSpPr>
+        <p:spPr>
+          <a:xfrm>
+            <a:off x="629328" y="464408"/>
+            <a:ext cx="4399872" cy="1642533"/>
+          </a:xfrm>
+        </p:spPr>
+        <p:txBody>
+          <a:bodyPr anchor="b">
+            <a:normAutofit/>
+          </a:bodyPr>
+          <a:lstStyle/>
+          <a:p>
+            <a:r>
+              <a:rPr lang="es-CO" sz="5400"/>
+              <a:t>EPICAS:</a:t>
+            </a:r>
+          </a:p>
+        </p:txBody>
+      </p:sp>
+      <p:sp>
+        <p:nvSpPr>
+          <p:cNvPr id="21" name="sketch line">
+            <a:extLst>
+              <a:ext uri="{FF2B5EF4-FFF2-40B4-BE49-F238E27FC236}">
+                <a16:creationId xmlns:a16="http://schemas.microsoft.com/office/drawing/2014/main" id="{3FCFB1DE-0B7E-48CC-BA90-B2AB0889F9D6}"/>
+              </a:ext>
+              <a:ext uri="{C183D7F6-B498-43B3-948B-1728B52AA6E4}">
+                <adec:decorative xmlns:adec="http://schemas.microsoft.com/office/drawing/2017/decorative" val="1"/>
+              </a:ext>
+            </a:extLst>
+          </p:cNvPr>
+          <p:cNvSpPr>
+            <a:spLocks noGrp="1" noRot="1" noChangeAspect="1" noMove="1" noResize="1" noEditPoints="1" noAdjustHandles="1" noChangeArrowheads="1" noChangeShapeType="1" noTextEdit="1"/>
+          </p:cNvSpPr>
+          <p:nvPr>
+            <p:extLst>
+              <p:ext uri="{386F3935-93C4-4BCD-93E2-E3B085C9AB24}">
+                <p16:designElem xmlns:p16="http://schemas.microsoft.com/office/powerpoint/2015/main" val="1"/>
+              </p:ext>
+            </p:extLst>
+          </p:nvPr>
+        </p:nvSpPr>
+        <p:spPr>
+          <a:xfrm>
+            <a:off x="629328" y="2457800"/>
+            <a:ext cx="3877056" cy="18288"/>
+          </a:xfrm>
+          <a:custGeom>
+            <a:avLst/>
+            <a:gdLst>
+              <a:gd name="csX0" fmla="*/ 0 w 3877056"/>
+              <a:gd name="csY0" fmla="*/ 0 h 18288"/>
+              <a:gd name="csX1" fmla="*/ 723717 w 3877056"/>
+              <a:gd name="csY1" fmla="*/ 0 h 18288"/>
+              <a:gd name="csX2" fmla="*/ 1447434 w 3877056"/>
+              <a:gd name="csY2" fmla="*/ 0 h 18288"/>
+              <a:gd name="csX3" fmla="*/ 1977299 w 3877056"/>
+              <a:gd name="csY3" fmla="*/ 0 h 18288"/>
+              <a:gd name="csX4" fmla="*/ 2623475 w 3877056"/>
+              <a:gd name="csY4" fmla="*/ 0 h 18288"/>
+              <a:gd name="csX5" fmla="*/ 3192109 w 3877056"/>
+              <a:gd name="csY5" fmla="*/ 0 h 18288"/>
+              <a:gd name="csX6" fmla="*/ 3877056 w 3877056"/>
+              <a:gd name="csY6" fmla="*/ 0 h 18288"/>
+              <a:gd name="csX7" fmla="*/ 3877056 w 3877056"/>
+              <a:gd name="csY7" fmla="*/ 18288 h 18288"/>
+              <a:gd name="csX8" fmla="*/ 3230880 w 3877056"/>
+              <a:gd name="csY8" fmla="*/ 18288 h 18288"/>
+              <a:gd name="csX9" fmla="*/ 2662245 w 3877056"/>
+              <a:gd name="csY9" fmla="*/ 18288 h 18288"/>
+              <a:gd name="csX10" fmla="*/ 2016069 w 3877056"/>
+              <a:gd name="csY10" fmla="*/ 18288 h 18288"/>
+              <a:gd name="csX11" fmla="*/ 1408664 w 3877056"/>
+              <a:gd name="csY11" fmla="*/ 18288 h 18288"/>
+              <a:gd name="csX12" fmla="*/ 840029 w 3877056"/>
+              <a:gd name="csY12" fmla="*/ 18288 h 18288"/>
+              <a:gd name="csX13" fmla="*/ 0 w 3877056"/>
+              <a:gd name="csY13" fmla="*/ 18288 h 18288"/>
+              <a:gd name="csX14" fmla="*/ 0 w 3877056"/>
+              <a:gd name="csY14" fmla="*/ 0 h 18288"/>
+            </a:gdLst>
+            <a:ahLst/>
+            <a:cxnLst>
+              <a:cxn ang="0">
+                <a:pos x="csX0" y="csY0"/>
+              </a:cxn>
+              <a:cxn ang="0">
+                <a:pos x="csX1" y="csY1"/>
+              </a:cxn>
+              <a:cxn ang="0">
+                <a:pos x="csX2" y="csY2"/>
+              </a:cxn>
+              <a:cxn ang="0">
+                <a:pos x="csX3" y="csY3"/>
+              </a:cxn>
+              <a:cxn ang="0">
+                <a:pos x="csX4" y="csY4"/>
+              </a:cxn>
+              <a:cxn ang="0">
+                <a:pos x="csX5" y="csY5"/>
+              </a:cxn>
+              <a:cxn ang="0">
+                <a:pos x="csX6" y="csY6"/>
+              </a:cxn>
+              <a:cxn ang="0">
+                <a:pos x="csX7" y="csY7"/>
+              </a:cxn>
+              <a:cxn ang="0">
+                <a:pos x="csX8" y="csY8"/>
+              </a:cxn>
+              <a:cxn ang="0">
+                <a:pos x="csX9" y="csY9"/>
+              </a:cxn>
+              <a:cxn ang="0">
+                <a:pos x="csX10" y="csY10"/>
+              </a:cxn>
+              <a:cxn ang="0">
+                <a:pos x="csX11" y="csY11"/>
+              </a:cxn>
+              <a:cxn ang="0">
+                <a:pos x="csX12" y="csY12"/>
+              </a:cxn>
+              <a:cxn ang="0">
+                <a:pos x="csX13" y="csY13"/>
+              </a:cxn>
+              <a:cxn ang="0">
+                <a:pos x="csX14" y="csY14"/>
+              </a:cxn>
+            </a:cxnLst>
+            <a:rect l="l" t="t" r="r" b="b"/>
+            <a:pathLst>
+              <a:path w="3877056" h="18288" fill="none" extrusionOk="0">
+                <a:moveTo>
+                  <a:pt x="0" y="0"/>
+                </a:moveTo>
+                <a:cubicBezTo>
+                  <a:pt x="155902" y="14477"/>
+                  <a:pt x="567164" y="18992"/>
+                  <a:pt x="723717" y="0"/>
+                </a:cubicBezTo>
+                <a:cubicBezTo>
+                  <a:pt x="880270" y="-18992"/>
+                  <a:pt x="1230427" y="-33316"/>
+                  <a:pt x="1447434" y="0"/>
+                </a:cubicBezTo>
+                <a:cubicBezTo>
+                  <a:pt x="1664441" y="33316"/>
+                  <a:pt x="1866557" y="5702"/>
+                  <a:pt x="1977299" y="0"/>
+                </a:cubicBezTo>
+                <a:cubicBezTo>
+                  <a:pt x="2088041" y="-5702"/>
+                  <a:pt x="2302485" y="24099"/>
+                  <a:pt x="2623475" y="0"/>
+                </a:cubicBezTo>
+                <a:cubicBezTo>
+                  <a:pt x="2944465" y="-24099"/>
+                  <a:pt x="2993399" y="-19795"/>
+                  <a:pt x="3192109" y="0"/>
+                </a:cubicBezTo>
+                <a:cubicBezTo>
+                  <a:pt x="3390819" y="19795"/>
+                  <a:pt x="3581349" y="-26551"/>
+                  <a:pt x="3877056" y="0"/>
+                </a:cubicBezTo>
+                <a:cubicBezTo>
+                  <a:pt x="3877095" y="7328"/>
+                  <a:pt x="3877675" y="9982"/>
+                  <a:pt x="3877056" y="18288"/>
+                </a:cubicBezTo>
+                <a:cubicBezTo>
+                  <a:pt x="3576596" y="42394"/>
+                  <a:pt x="3502355" y="16962"/>
+                  <a:pt x="3230880" y="18288"/>
+                </a:cubicBezTo>
+                <a:cubicBezTo>
+                  <a:pt x="2959405" y="19614"/>
+                  <a:pt x="2924948" y="18543"/>
+                  <a:pt x="2662245" y="18288"/>
+                </a:cubicBezTo>
+                <a:cubicBezTo>
+                  <a:pt x="2399543" y="18033"/>
+                  <a:pt x="2231855" y="26028"/>
+                  <a:pt x="2016069" y="18288"/>
+                </a:cubicBezTo>
+                <a:cubicBezTo>
+                  <a:pt x="1800283" y="10548"/>
+                  <a:pt x="1665927" y="755"/>
+                  <a:pt x="1408664" y="18288"/>
+                </a:cubicBezTo>
+                <a:cubicBezTo>
+                  <a:pt x="1151402" y="35821"/>
+                  <a:pt x="1016899" y="28407"/>
+                  <a:pt x="840029" y="18288"/>
+                </a:cubicBezTo>
+                <a:cubicBezTo>
+                  <a:pt x="663160" y="8169"/>
+                  <a:pt x="304031" y="-14425"/>
+                  <a:pt x="0" y="18288"/>
+                </a:cubicBezTo>
+                <a:cubicBezTo>
+                  <a:pt x="-593" y="9736"/>
+                  <a:pt x="244" y="6610"/>
+                  <a:pt x="0" y="0"/>
+                </a:cubicBezTo>
+                <a:close/>
+              </a:path>
+              <a:path w="3877056" h="18288" stroke="0" extrusionOk="0">
+                <a:moveTo>
+                  <a:pt x="0" y="0"/>
+                </a:moveTo>
+                <a:cubicBezTo>
+                  <a:pt x="205869" y="28368"/>
+                  <a:pt x="460328" y="6409"/>
+                  <a:pt x="646176" y="0"/>
+                </a:cubicBezTo>
+                <a:cubicBezTo>
+                  <a:pt x="832024" y="-6409"/>
+                  <a:pt x="1043494" y="26447"/>
+                  <a:pt x="1331123" y="0"/>
+                </a:cubicBezTo>
+                <a:cubicBezTo>
+                  <a:pt x="1618752" y="-26447"/>
+                  <a:pt x="1675797" y="-26969"/>
+                  <a:pt x="1938528" y="0"/>
+                </a:cubicBezTo>
+                <a:cubicBezTo>
+                  <a:pt x="2201259" y="26969"/>
+                  <a:pt x="2439942" y="23453"/>
+                  <a:pt x="2662245" y="0"/>
+                </a:cubicBezTo>
+                <a:cubicBezTo>
+                  <a:pt x="2884548" y="-23453"/>
+                  <a:pt x="3094562" y="-7899"/>
+                  <a:pt x="3308421" y="0"/>
+                </a:cubicBezTo>
+                <a:cubicBezTo>
+                  <a:pt x="3522280" y="7899"/>
+                  <a:pt x="3615459" y="3066"/>
+                  <a:pt x="3877056" y="0"/>
+                </a:cubicBezTo>
+                <a:cubicBezTo>
+                  <a:pt x="3877383" y="8595"/>
+                  <a:pt x="3876984" y="13110"/>
+                  <a:pt x="3877056" y="18288"/>
+                </a:cubicBezTo>
+                <a:cubicBezTo>
+                  <a:pt x="3624575" y="4903"/>
+                  <a:pt x="3478089" y="20597"/>
+                  <a:pt x="3230880" y="18288"/>
+                </a:cubicBezTo>
+                <a:cubicBezTo>
+                  <a:pt x="2983671" y="15979"/>
+                  <a:pt x="2743376" y="19903"/>
+                  <a:pt x="2507163" y="18288"/>
+                </a:cubicBezTo>
+                <a:cubicBezTo>
+                  <a:pt x="2270950" y="16673"/>
+                  <a:pt x="1992617" y="19013"/>
+                  <a:pt x="1822216" y="18288"/>
+                </a:cubicBezTo>
+                <a:cubicBezTo>
+                  <a:pt x="1651815" y="17563"/>
+                  <a:pt x="1370782" y="42338"/>
+                  <a:pt x="1253581" y="18288"/>
+                </a:cubicBezTo>
+                <a:cubicBezTo>
+                  <a:pt x="1136380" y="-5762"/>
+                  <a:pt x="854528" y="8046"/>
+                  <a:pt x="723717" y="18288"/>
+                </a:cubicBezTo>
+                <a:cubicBezTo>
+                  <a:pt x="592906" y="28530"/>
+                  <a:pt x="166343" y="24405"/>
+                  <a:pt x="0" y="18288"/>
+                </a:cubicBezTo>
+                <a:cubicBezTo>
+                  <a:pt x="822" y="10564"/>
+                  <a:pt x="-23" y="4571"/>
+                  <a:pt x="0" y="0"/>
+                </a:cubicBezTo>
+                <a:close/>
+              </a:path>
+            </a:pathLst>
+          </a:custGeom>
+          <a:solidFill>
+            <a:schemeClr val="accent2"/>
+          </a:solidFill>
+          <a:ln w="41275" cap="rnd">
+            <a:solidFill>
+              <a:schemeClr val="accent2"/>
+            </a:solidFill>
+            <a:round/>
+            <a:extLst>
+              <a:ext uri="{C807C97D-BFC1-408E-A445-0C87EB9F89A2}">
+                <ask:lineSketchStyleProps xmlns:ask="http://schemas.microsoft.com/office/drawing/2018/sketchyshapes" sd="2448976505">
+                  <a:prstGeom prst="rect">
+                    <a:avLst/>
+                  </a:prstGeom>
+                  <ask:type>
+                    <ask:lineSketchFreehand/>
+                  </ask:type>
+                </ask:lineSketchStyleProps>
+              </a:ext>
+            </a:extLst>
+          </a:ln>
+        </p:spPr>
+        <p:style>
+          <a:lnRef idx="2">
+            <a:schemeClr val="accent1">
+              <a:shade val="50000"/>
+            </a:schemeClr>
+          </a:lnRef>
+          <a:fillRef idx="1">
+            <a:schemeClr val="accent1"/>
+          </a:fillRef>
+          <a:effectRef idx="0">
+            <a:schemeClr val="accent1"/>
+          </a:effectRef>
+          <a:fontRef idx="minor">
+            <a:schemeClr val="lt1"/>
+          </a:fontRef>
+        </p:style>
+        <p:txBody>
+          <a:bodyPr rtlCol="0" anchor="ctr"/>
+          <a:lstStyle/>
+          <a:p>
+            <a:pPr algn="ctr"/>
+            <a:endParaRPr lang="en-US"/>
+          </a:p>
+        </p:txBody>
+      </p:sp>
+      <p:sp>
+        <p:nvSpPr>
+          <p:cNvPr id="3" name="Marcador de contenido 2">
+            <a:extLst>
+              <a:ext uri="{FF2B5EF4-FFF2-40B4-BE49-F238E27FC236}">
+                <a16:creationId xmlns:a16="http://schemas.microsoft.com/office/drawing/2014/main" id="{CCCC1410-C5AC-F531-D2B6-B189DCBFF5CF}"/>
+              </a:ext>
+            </a:extLst>
+          </p:cNvPr>
+          <p:cNvSpPr>
+            <a:spLocks noGrp="1"/>
+          </p:cNvSpPr>
+          <p:nvPr>
+            <p:ph idx="1"/>
+          </p:nvPr>
+        </p:nvSpPr>
+        <p:spPr>
+          <a:xfrm>
+            <a:off x="629489" y="2741264"/>
+            <a:ext cx="4404039" cy="3386399"/>
+          </a:xfrm>
+        </p:spPr>
+        <p:txBody>
+          <a:bodyPr>
+            <a:normAutofit/>
+          </a:bodyPr>
+          <a:lstStyle/>
+          <a:p>
+            <a:r>
+              <a:rPr lang="es-CO" sz="2200"/>
+              <a:t>Gestión del catálogo</a:t>
+            </a:r>
+          </a:p>
+          <a:p>
+            <a:pPr marL="0" indent="0">
+              <a:buNone/>
+            </a:pPr>
+            <a:r>
+              <a:rPr lang="es-CO" sz="2200"/>
+              <a:t> </a:t>
+            </a:r>
+          </a:p>
+          <a:p>
+            <a:r>
+              <a:rPr lang="es-CO" sz="2200"/>
+              <a:t>Gestión de usuarios</a:t>
+            </a:r>
+          </a:p>
+          <a:p>
+            <a:pPr marL="0" indent="0">
+              <a:buNone/>
+            </a:pPr>
+            <a:endParaRPr lang="es-CO" sz="2200"/>
+          </a:p>
+          <a:p>
+            <a:r>
+              <a:rPr lang="es-CO" sz="2200"/>
+              <a:t>Ventas  y checkout </a:t>
+            </a:r>
+          </a:p>
+          <a:p>
+            <a:pPr marL="0" indent="0">
+              <a:buNone/>
+            </a:pPr>
+            <a:endParaRPr lang="es-CO" sz="2200"/>
+          </a:p>
+          <a:p>
+            <a:r>
+              <a:rPr lang="es-CO" sz="2200"/>
+              <a:t>Soporte y atención al cliente </a:t>
+            </a:r>
+          </a:p>
+        </p:txBody>
+      </p:sp>
+      <p:pic>
+        <p:nvPicPr>
+          <p:cNvPr id="5" name="Imagen 4">
+            <a:extLst>
+              <a:ext uri="{FF2B5EF4-FFF2-40B4-BE49-F238E27FC236}">
+                <a16:creationId xmlns:a16="http://schemas.microsoft.com/office/drawing/2014/main" id="{BAD00D11-5FFB-2499-3688-4483045621B1}"/>
+              </a:ext>
+            </a:extLst>
+          </p:cNvPr>
+          <p:cNvPicPr>
+            <a:picLocks noChangeAspect="1"/>
+          </p:cNvPicPr>
+          <p:nvPr/>
+        </p:nvPicPr>
+        <p:blipFill>
+          <a:blip r:embed="rId2"/>
+          <a:srcRect r="961" b="5"/>
+          <a:stretch>
+            <a:fillRect/>
+          </a:stretch>
+        </p:blipFill>
+        <p:spPr>
+          <a:xfrm>
+            <a:off x="5376648" y="448967"/>
+            <a:ext cx="2800021" cy="2607952"/>
+          </a:xfrm>
+          <a:custGeom>
+            <a:avLst/>
+            <a:gdLst/>
+            <a:ahLst/>
+            <a:cxnLst/>
+            <a:rect l="l" t="t" r="r" b="b"/>
+            <a:pathLst>
+              <a:path w="2800021" h="2607952">
+                <a:moveTo>
+                  <a:pt x="1896921" y="1283"/>
+                </a:moveTo>
+                <a:cubicBezTo>
+                  <a:pt x="1964079" y="3763"/>
+                  <a:pt x="2031133" y="9836"/>
+                  <a:pt x="2097856" y="19493"/>
+                </a:cubicBezTo>
+                <a:cubicBezTo>
+                  <a:pt x="2197875" y="35580"/>
+                  <a:pt x="2298741" y="25628"/>
+                  <a:pt x="2399244" y="18812"/>
+                </a:cubicBezTo>
+                <a:cubicBezTo>
+                  <a:pt x="2520913" y="10497"/>
+                  <a:pt x="2642460" y="5999"/>
+                  <a:pt x="2764369" y="19631"/>
+                </a:cubicBezTo>
+                <a:lnTo>
+                  <a:pt x="2781331" y="20066"/>
+                </a:lnTo>
+                <a:lnTo>
+                  <a:pt x="2771027" y="223244"/>
+                </a:lnTo>
+                <a:cubicBezTo>
+                  <a:pt x="2770027" y="306498"/>
+                  <a:pt x="2772785" y="389724"/>
+                  <a:pt x="2780906" y="472842"/>
+                </a:cubicBezTo>
+                <a:cubicBezTo>
+                  <a:pt x="2793852" y="625932"/>
+                  <a:pt x="2795719" y="779623"/>
+                  <a:pt x="2786483" y="932933"/>
+                </a:cubicBezTo>
+                <a:cubicBezTo>
+                  <a:pt x="2780058" y="1071462"/>
+                  <a:pt x="2764299" y="1209772"/>
+                  <a:pt x="2777754" y="1348629"/>
+                </a:cubicBezTo>
+                <a:cubicBezTo>
+                  <a:pt x="2782361" y="1396405"/>
+                  <a:pt x="2793512" y="1443308"/>
+                  <a:pt x="2796058" y="1491412"/>
+                </a:cubicBezTo>
+                <a:cubicBezTo>
+                  <a:pt x="2808180" y="1716767"/>
+                  <a:pt x="2789997" y="1941359"/>
+                  <a:pt x="2775088" y="2165950"/>
+                </a:cubicBezTo>
+                <a:cubicBezTo>
+                  <a:pt x="2769633" y="2247759"/>
+                  <a:pt x="2762966" y="2329567"/>
+                  <a:pt x="2777876" y="2411376"/>
+                </a:cubicBezTo>
+                <a:cubicBezTo>
+                  <a:pt x="2783785" y="2445894"/>
+                  <a:pt x="2787349" y="2480670"/>
+                  <a:pt x="2788562" y="2515512"/>
+                </a:cubicBezTo>
+                <a:lnTo>
+                  <a:pt x="2785862" y="2598193"/>
+                </a:lnTo>
+                <a:lnTo>
+                  <a:pt x="2765823" y="2598670"/>
+                </a:lnTo>
+                <a:cubicBezTo>
+                  <a:pt x="2658539" y="2600165"/>
+                  <a:pt x="2550823" y="2613972"/>
+                  <a:pt x="2444081" y="2598670"/>
+                </a:cubicBezTo>
+                <a:cubicBezTo>
+                  <a:pt x="2255735" y="2573645"/>
+                  <a:pt x="2065408" y="2570205"/>
+                  <a:pt x="1876379" y="2588429"/>
+                </a:cubicBezTo>
+                <a:cubicBezTo>
+                  <a:pt x="1663187" y="2606148"/>
+                  <a:pt x="1449075" y="2607414"/>
+                  <a:pt x="1235711" y="2592226"/>
+                </a:cubicBezTo>
+                <a:cubicBezTo>
+                  <a:pt x="1077655" y="2581411"/>
+                  <a:pt x="919274" y="2573358"/>
+                  <a:pt x="760677" y="2583023"/>
+                </a:cubicBezTo>
+                <a:cubicBezTo>
+                  <a:pt x="699945" y="2586819"/>
+                  <a:pt x="640728" y="2603387"/>
+                  <a:pt x="580211" y="2605228"/>
+                </a:cubicBezTo>
+                <a:cubicBezTo>
+                  <a:pt x="409739" y="2610520"/>
+                  <a:pt x="239309" y="2608104"/>
+                  <a:pt x="68912" y="2597979"/>
+                </a:cubicBezTo>
+                <a:lnTo>
+                  <a:pt x="9851" y="2595036"/>
+                </a:lnTo>
+                <a:lnTo>
+                  <a:pt x="14918" y="2533474"/>
+                </a:lnTo>
+                <a:cubicBezTo>
+                  <a:pt x="24226" y="2470964"/>
+                  <a:pt x="33057" y="2409078"/>
+                  <a:pt x="21123" y="2345943"/>
+                </a:cubicBezTo>
+                <a:cubicBezTo>
+                  <a:pt x="15873" y="2318439"/>
+                  <a:pt x="11935" y="2290684"/>
+                  <a:pt x="9189" y="2262929"/>
+                </a:cubicBezTo>
+                <a:cubicBezTo>
+                  <a:pt x="3723" y="2192068"/>
+                  <a:pt x="5681" y="2120806"/>
+                  <a:pt x="15036" y="2050394"/>
+                </a:cubicBezTo>
+                <a:cubicBezTo>
+                  <a:pt x="23988" y="1968631"/>
+                  <a:pt x="9428" y="1886367"/>
+                  <a:pt x="21362" y="1804853"/>
+                </a:cubicBezTo>
+                <a:cubicBezTo>
+                  <a:pt x="29835" y="1739206"/>
+                  <a:pt x="30157" y="1672681"/>
+                  <a:pt x="22317" y="1606945"/>
+                </a:cubicBezTo>
+                <a:cubicBezTo>
+                  <a:pt x="8211" y="1482675"/>
+                  <a:pt x="9093" y="1357041"/>
+                  <a:pt x="24942" y="1233009"/>
+                </a:cubicBezTo>
+                <a:cubicBezTo>
+                  <a:pt x="34728" y="1160621"/>
+                  <a:pt x="40337" y="1086110"/>
+                  <a:pt x="22794" y="1015097"/>
+                </a:cubicBezTo>
+                <a:cubicBezTo>
+                  <a:pt x="-18498" y="848195"/>
+                  <a:pt x="5610" y="681043"/>
+                  <a:pt x="22794" y="515015"/>
+                </a:cubicBezTo>
+                <a:cubicBezTo>
+                  <a:pt x="33236" y="425851"/>
+                  <a:pt x="33475" y="335698"/>
+                  <a:pt x="23510" y="246472"/>
+                </a:cubicBezTo>
+                <a:cubicBezTo>
+                  <a:pt x="14667" y="180579"/>
+                  <a:pt x="9392" y="114270"/>
+                  <a:pt x="7698" y="47862"/>
+                </a:cubicBezTo>
+                <a:lnTo>
+                  <a:pt x="8577" y="16981"/>
+                </a:lnTo>
+                <a:lnTo>
+                  <a:pt x="105876" y="19483"/>
+                </a:lnTo>
+                <a:cubicBezTo>
+                  <a:pt x="269744" y="18941"/>
+                  <a:pt x="433357" y="6953"/>
+                  <a:pt x="596356" y="8998"/>
+                </a:cubicBezTo>
+                <a:cubicBezTo>
+                  <a:pt x="687063" y="10088"/>
+                  <a:pt x="777528" y="30535"/>
+                  <a:pt x="868476" y="26719"/>
+                </a:cubicBezTo>
+                <a:cubicBezTo>
+                  <a:pt x="1144104" y="15541"/>
+                  <a:pt x="1419853" y="19221"/>
+                  <a:pt x="1695360" y="4635"/>
+                </a:cubicBezTo>
+                <a:cubicBezTo>
+                  <a:pt x="1762501" y="-82"/>
+                  <a:pt x="1829763" y="-1196"/>
+                  <a:pt x="1896921" y="1283"/>
+                </a:cubicBezTo>
+                <a:close/>
+              </a:path>
+            </a:pathLst>
+          </a:custGeom>
+        </p:spPr>
+      </p:pic>
+      <p:pic>
+        <p:nvPicPr>
+          <p:cNvPr id="9" name="Imagen 8">
+            <a:extLst>
+              <a:ext uri="{FF2B5EF4-FFF2-40B4-BE49-F238E27FC236}">
+                <a16:creationId xmlns:a16="http://schemas.microsoft.com/office/drawing/2014/main" id="{8D7750A8-836F-0032-CCAA-A156E5E52B94}"/>
+              </a:ext>
+            </a:extLst>
+          </p:cNvPr>
+          <p:cNvPicPr>
+            <a:picLocks noChangeAspect="1"/>
+          </p:cNvPicPr>
+          <p:nvPr/>
+        </p:nvPicPr>
+        <p:blipFill>
+          <a:blip r:embed="rId3"/>
+          <a:srcRect r="7204" b="6"/>
+          <a:stretch>
+            <a:fillRect/>
+          </a:stretch>
+        </p:blipFill>
+        <p:spPr>
+          <a:xfrm>
+            <a:off x="5371395" y="3215684"/>
+            <a:ext cx="2809123" cy="3034623"/>
+          </a:xfrm>
+          <a:custGeom>
+            <a:avLst/>
+            <a:gdLst/>
+            <a:ahLst/>
+            <a:cxnLst/>
+            <a:rect l="l" t="t" r="r" b="b"/>
+            <a:pathLst>
+              <a:path w="2809123" h="3034623">
+                <a:moveTo>
+                  <a:pt x="909359" y="1412"/>
+                </a:moveTo>
+                <a:cubicBezTo>
+                  <a:pt x="958144" y="-855"/>
+                  <a:pt x="1007041" y="-392"/>
+                  <a:pt x="1055844" y="2812"/>
+                </a:cubicBezTo>
+                <a:cubicBezTo>
+                  <a:pt x="1188892" y="11671"/>
+                  <a:pt x="1321724" y="23752"/>
+                  <a:pt x="1455098" y="27433"/>
+                </a:cubicBezTo>
+                <a:cubicBezTo>
+                  <a:pt x="1585007" y="30886"/>
+                  <a:pt x="1714916" y="19724"/>
+                  <a:pt x="1844174" y="11211"/>
+                </a:cubicBezTo>
+                <a:cubicBezTo>
+                  <a:pt x="2032760" y="-1215"/>
+                  <a:pt x="2221452" y="7644"/>
+                  <a:pt x="2410145" y="15353"/>
+                </a:cubicBezTo>
+                <a:cubicBezTo>
+                  <a:pt x="2481555" y="18287"/>
+                  <a:pt x="2552964" y="17014"/>
+                  <a:pt x="2624374" y="15060"/>
+                </a:cubicBezTo>
+                <a:lnTo>
+                  <a:pt x="2784992" y="11774"/>
+                </a:lnTo>
+                <a:lnTo>
+                  <a:pt x="2785432" y="38761"/>
+                </a:lnTo>
+                <a:cubicBezTo>
+                  <a:pt x="2800584" y="206742"/>
+                  <a:pt x="2808948" y="374831"/>
+                  <a:pt x="2808827" y="543247"/>
+                </a:cubicBezTo>
+                <a:cubicBezTo>
+                  <a:pt x="2810305" y="612173"/>
+                  <a:pt x="2806257" y="681111"/>
+                  <a:pt x="2796705" y="749514"/>
+                </a:cubicBezTo>
+                <a:cubicBezTo>
+                  <a:pt x="2780583" y="847684"/>
+                  <a:pt x="2768461" y="946836"/>
+                  <a:pt x="2778522" y="1046533"/>
+                </a:cubicBezTo>
+                <a:cubicBezTo>
+                  <a:pt x="2785553" y="1115252"/>
+                  <a:pt x="2789675" y="1183862"/>
+                  <a:pt x="2789432" y="1252908"/>
+                </a:cubicBezTo>
+                <a:cubicBezTo>
+                  <a:pt x="2789432" y="1411618"/>
+                  <a:pt x="2787978" y="1570434"/>
+                  <a:pt x="2791008" y="1729144"/>
+                </a:cubicBezTo>
+                <a:cubicBezTo>
+                  <a:pt x="2793675" y="1870399"/>
+                  <a:pt x="2799493" y="2011110"/>
+                  <a:pt x="2784826" y="2152475"/>
+                </a:cubicBezTo>
+                <a:cubicBezTo>
+                  <a:pt x="2763249" y="2361141"/>
+                  <a:pt x="2770159" y="2570898"/>
+                  <a:pt x="2772704" y="2780218"/>
+                </a:cubicBezTo>
+                <a:lnTo>
+                  <a:pt x="2785201" y="3024103"/>
+                </a:lnTo>
+                <a:lnTo>
+                  <a:pt x="2729575" y="3019707"/>
+                </a:lnTo>
+                <a:cubicBezTo>
+                  <a:pt x="2664468" y="3010397"/>
+                  <a:pt x="2600011" y="3001566"/>
+                  <a:pt x="2534253" y="3013501"/>
+                </a:cubicBezTo>
+                <a:cubicBezTo>
+                  <a:pt x="2505606" y="3018752"/>
+                  <a:pt x="2476698" y="3022690"/>
+                  <a:pt x="2447790" y="3025435"/>
+                </a:cubicBezTo>
+                <a:cubicBezTo>
+                  <a:pt x="2373985" y="3030901"/>
+                  <a:pt x="2299762" y="3028945"/>
+                  <a:pt x="2226426" y="3019587"/>
+                </a:cubicBezTo>
+                <a:cubicBezTo>
+                  <a:pt x="2141266" y="3010636"/>
+                  <a:pt x="2055584" y="3025196"/>
+                  <a:pt x="1970684" y="3013262"/>
+                </a:cubicBezTo>
+                <a:cubicBezTo>
+                  <a:pt x="1902309" y="3004788"/>
+                  <a:pt x="1833021" y="3004466"/>
+                  <a:pt x="1764554" y="3012307"/>
+                </a:cubicBezTo>
+                <a:cubicBezTo>
+                  <a:pt x="1635120" y="3026413"/>
+                  <a:pt x="1504268" y="3025530"/>
+                  <a:pt x="1375082" y="3009682"/>
+                </a:cubicBezTo>
+                <a:cubicBezTo>
+                  <a:pt x="1299687" y="2999895"/>
+                  <a:pt x="1222081" y="2994286"/>
+                  <a:pt x="1148118" y="3011830"/>
+                </a:cubicBezTo>
+                <a:cubicBezTo>
+                  <a:pt x="974281" y="3053123"/>
+                  <a:pt x="800184" y="3029015"/>
+                  <a:pt x="627259" y="3011830"/>
+                </a:cubicBezTo>
+                <a:cubicBezTo>
+                  <a:pt x="534391" y="3001387"/>
+                  <a:pt x="440493" y="3001148"/>
+                  <a:pt x="347559" y="3011113"/>
+                </a:cubicBezTo>
+                <a:cubicBezTo>
+                  <a:pt x="278929" y="3019957"/>
+                  <a:pt x="209866" y="3025232"/>
+                  <a:pt x="140699" y="3026927"/>
+                </a:cubicBezTo>
+                <a:lnTo>
+                  <a:pt x="44501" y="3024299"/>
+                </a:lnTo>
+                <a:lnTo>
+                  <a:pt x="26973" y="2893528"/>
+                </a:lnTo>
+                <a:cubicBezTo>
+                  <a:pt x="-4174" y="2764506"/>
+                  <a:pt x="-10619" y="2635110"/>
+                  <a:pt x="19693" y="2504963"/>
+                </a:cubicBezTo>
+                <a:cubicBezTo>
+                  <a:pt x="48311" y="2384006"/>
+                  <a:pt x="46914" y="2257385"/>
+                  <a:pt x="15637" y="2137152"/>
+                </a:cubicBezTo>
+                <a:cubicBezTo>
+                  <a:pt x="8714" y="2106022"/>
+                  <a:pt x="4478" y="2074304"/>
+                  <a:pt x="2986" y="2042386"/>
+                </a:cubicBezTo>
+                <a:cubicBezTo>
+                  <a:pt x="-6442" y="1925867"/>
+                  <a:pt x="9430" y="1810973"/>
+                  <a:pt x="22676" y="1695829"/>
+                </a:cubicBezTo>
+                <a:cubicBezTo>
+                  <a:pt x="31508" y="1622442"/>
+                  <a:pt x="44993" y="1548304"/>
+                  <a:pt x="22676" y="1475668"/>
+                </a:cubicBezTo>
+                <a:cubicBezTo>
+                  <a:pt x="7389" y="1425047"/>
+                  <a:pt x="3989" y="1371313"/>
+                  <a:pt x="12773" y="1319017"/>
+                </a:cubicBezTo>
+                <a:cubicBezTo>
+                  <a:pt x="27582" y="1226202"/>
+                  <a:pt x="30672" y="1131749"/>
+                  <a:pt x="21961" y="1038096"/>
+                </a:cubicBezTo>
+                <a:cubicBezTo>
+                  <a:pt x="16209" y="976348"/>
+                  <a:pt x="17092" y="914112"/>
+                  <a:pt x="24587" y="852564"/>
+                </a:cubicBezTo>
+                <a:cubicBezTo>
+                  <a:pt x="34491" y="769801"/>
+                  <a:pt x="49886" y="685536"/>
+                  <a:pt x="31150" y="602524"/>
+                </a:cubicBezTo>
+                <a:cubicBezTo>
+                  <a:pt x="1315" y="470626"/>
+                  <a:pt x="7282" y="338854"/>
+                  <a:pt x="19217" y="205958"/>
+                </a:cubicBezTo>
+                <a:cubicBezTo>
+                  <a:pt x="23692" y="156512"/>
+                  <a:pt x="28406" y="106785"/>
+                  <a:pt x="29763" y="56918"/>
+                </a:cubicBezTo>
+                <a:lnTo>
+                  <a:pt x="29335" y="22484"/>
+                </a:lnTo>
+                <a:lnTo>
+                  <a:pt x="182423" y="11326"/>
+                </a:lnTo>
+                <a:cubicBezTo>
+                  <a:pt x="307134" y="-180"/>
+                  <a:pt x="431415" y="11326"/>
+                  <a:pt x="556126" y="18689"/>
+                </a:cubicBezTo>
+                <a:cubicBezTo>
+                  <a:pt x="625195" y="22602"/>
+                  <a:pt x="694588" y="27319"/>
+                  <a:pt x="763549" y="16388"/>
+                </a:cubicBezTo>
+                <a:cubicBezTo>
+                  <a:pt x="811902" y="8674"/>
+                  <a:pt x="860574" y="3678"/>
+                  <a:pt x="909359" y="1412"/>
+                </a:cubicBezTo>
+                <a:close/>
+              </a:path>
+            </a:pathLst>
+          </a:custGeom>
+        </p:spPr>
+      </p:pic>
+      <p:pic>
+        <p:nvPicPr>
+          <p:cNvPr id="7" name="Imagen 6">
+            <a:extLst>
+              <a:ext uri="{FF2B5EF4-FFF2-40B4-BE49-F238E27FC236}">
+                <a16:creationId xmlns:a16="http://schemas.microsoft.com/office/drawing/2014/main" id="{E4C839D6-DEDD-8C98-6B9E-3985065E79C1}"/>
+              </a:ext>
+            </a:extLst>
+          </p:cNvPr>
+          <p:cNvPicPr>
+            <a:picLocks noChangeAspect="1"/>
+          </p:cNvPicPr>
+          <p:nvPr/>
+        </p:nvPicPr>
+        <p:blipFill>
+          <a:blip r:embed="rId4"/>
+          <a:srcRect l="11591" r="13854" b="-4"/>
+          <a:stretch>
+            <a:fillRect/>
+          </a:stretch>
+        </p:blipFill>
+        <p:spPr>
+          <a:xfrm>
+            <a:off x="8344949" y="453323"/>
+            <a:ext cx="3451906" cy="3553662"/>
+          </a:xfrm>
+          <a:custGeom>
+            <a:avLst/>
+            <a:gdLst/>
+            <a:ahLst/>
+            <a:cxnLst/>
+            <a:rect l="l" t="t" r="r" b="b"/>
+            <a:pathLst>
+              <a:path w="3451906" h="3553662">
+                <a:moveTo>
+                  <a:pt x="723689" y="906"/>
+                </a:moveTo>
+                <a:cubicBezTo>
+                  <a:pt x="772066" y="2729"/>
+                  <a:pt x="820443" y="7023"/>
+                  <a:pt x="868820" y="11181"/>
+                </a:cubicBezTo>
+                <a:cubicBezTo>
+                  <a:pt x="1039107" y="26039"/>
+                  <a:pt x="1209273" y="19359"/>
+                  <a:pt x="1379198" y="8454"/>
+                </a:cubicBezTo>
+                <a:cubicBezTo>
+                  <a:pt x="1496186" y="1474"/>
+                  <a:pt x="1613486" y="5305"/>
+                  <a:pt x="1729930" y="19904"/>
+                </a:cubicBezTo>
+                <a:lnTo>
+                  <a:pt x="1770732" y="22354"/>
+                </a:lnTo>
+                <a:lnTo>
+                  <a:pt x="1793470" y="25525"/>
+                </a:lnTo>
+                <a:lnTo>
+                  <a:pt x="1895014" y="29765"/>
+                </a:lnTo>
+                <a:lnTo>
+                  <a:pt x="1895984" y="30265"/>
+                </a:lnTo>
+                <a:lnTo>
+                  <a:pt x="1908078" y="30265"/>
+                </a:lnTo>
+                <a:lnTo>
+                  <a:pt x="1909048" y="29667"/>
+                </a:lnTo>
+                <a:lnTo>
+                  <a:pt x="2008240" y="25525"/>
+                </a:lnTo>
+                <a:lnTo>
+                  <a:pt x="2081672" y="15283"/>
+                </a:lnTo>
+                <a:lnTo>
+                  <a:pt x="2184918" y="9562"/>
+                </a:lnTo>
+                <a:cubicBezTo>
+                  <a:pt x="2268544" y="8356"/>
+                  <a:pt x="2352209" y="10573"/>
+                  <a:pt x="2435750" y="16224"/>
+                </a:cubicBezTo>
+                <a:cubicBezTo>
+                  <a:pt x="2589588" y="24540"/>
+                  <a:pt x="2743185" y="15952"/>
+                  <a:pt x="2896904" y="5864"/>
+                </a:cubicBezTo>
+                <a:cubicBezTo>
+                  <a:pt x="2988276" y="-133"/>
+                  <a:pt x="3079618" y="1639"/>
+                  <a:pt x="3170959" y="5268"/>
+                </a:cubicBezTo>
+                <a:lnTo>
+                  <a:pt x="3437940" y="15543"/>
+                </a:lnTo>
+                <a:lnTo>
+                  <a:pt x="3440062" y="77084"/>
+                </a:lnTo>
+                <a:cubicBezTo>
+                  <a:pt x="3439759" y="207598"/>
+                  <a:pt x="3426999" y="337557"/>
+                  <a:pt x="3419542" y="467764"/>
+                </a:cubicBezTo>
+                <a:cubicBezTo>
+                  <a:pt x="3416314" y="527314"/>
+                  <a:pt x="3411472" y="587156"/>
+                  <a:pt x="3410666" y="646723"/>
+                </a:cubicBezTo>
+                <a:cubicBezTo>
+                  <a:pt x="3409858" y="706293"/>
+                  <a:pt x="3413086" y="765586"/>
+                  <a:pt x="3425999" y="824040"/>
+                </a:cubicBezTo>
+                <a:cubicBezTo>
+                  <a:pt x="3458153" y="973974"/>
+                  <a:pt x="3447305" y="1120693"/>
+                  <a:pt x="3425999" y="1269168"/>
+                </a:cubicBezTo>
+                <a:cubicBezTo>
+                  <a:pt x="3415281" y="1344279"/>
+                  <a:pt x="3402111" y="1421878"/>
+                  <a:pt x="3425353" y="1494944"/>
+                </a:cubicBezTo>
+                <a:cubicBezTo>
+                  <a:pt x="3464867" y="1616236"/>
+                  <a:pt x="3452342" y="1736506"/>
+                  <a:pt x="3438266" y="1858381"/>
+                </a:cubicBezTo>
+                <a:cubicBezTo>
+                  <a:pt x="3429228" y="1937294"/>
+                  <a:pt x="3419930" y="2017084"/>
+                  <a:pt x="3430518" y="2095996"/>
+                </a:cubicBezTo>
+                <a:cubicBezTo>
+                  <a:pt x="3446660" y="2216411"/>
+                  <a:pt x="3439170" y="2335949"/>
+                  <a:pt x="3431293" y="2456072"/>
+                </a:cubicBezTo>
+                <a:cubicBezTo>
+                  <a:pt x="3426129" y="2537469"/>
+                  <a:pt x="3413086" y="2619889"/>
+                  <a:pt x="3430002" y="2700556"/>
+                </a:cubicBezTo>
+                <a:cubicBezTo>
+                  <a:pt x="3441812" y="2765790"/>
+                  <a:pt x="3444254" y="2832749"/>
+                  <a:pt x="3437233" y="2898861"/>
+                </a:cubicBezTo>
+                <a:cubicBezTo>
+                  <a:pt x="3429485" y="3003493"/>
+                  <a:pt x="3415798" y="3108125"/>
+                  <a:pt x="3435297" y="3213050"/>
+                </a:cubicBezTo>
+                <a:cubicBezTo>
+                  <a:pt x="3445497" y="3268582"/>
+                  <a:pt x="3441754" y="3324843"/>
+                  <a:pt x="3438137" y="3380812"/>
+                </a:cubicBezTo>
+                <a:lnTo>
+                  <a:pt x="3429447" y="3533975"/>
+                </a:lnTo>
+                <a:lnTo>
+                  <a:pt x="3428457" y="3533971"/>
+                </a:lnTo>
+                <a:cubicBezTo>
+                  <a:pt x="3362736" y="3534214"/>
+                  <a:pt x="3297429" y="3530092"/>
+                  <a:pt x="3232020" y="3523062"/>
+                </a:cubicBezTo>
+                <a:cubicBezTo>
+                  <a:pt x="3137124" y="3513000"/>
+                  <a:pt x="3042746" y="3525122"/>
+                  <a:pt x="2949304" y="3541245"/>
+                </a:cubicBezTo>
+                <a:cubicBezTo>
+                  <a:pt x="2884196" y="3550796"/>
+                  <a:pt x="2818577" y="3554844"/>
+                  <a:pt x="2752970" y="3553366"/>
+                </a:cubicBezTo>
+                <a:cubicBezTo>
+                  <a:pt x="2592664" y="3553487"/>
+                  <a:pt x="2432670" y="3545124"/>
+                  <a:pt x="2272778" y="3529971"/>
+                </a:cubicBezTo>
+                <a:cubicBezTo>
+                  <a:pt x="2213920" y="3526298"/>
+                  <a:pt x="2154916" y="3527959"/>
+                  <a:pt x="2096275" y="3534941"/>
+                </a:cubicBezTo>
+                <a:cubicBezTo>
+                  <a:pt x="2030066" y="3541923"/>
+                  <a:pt x="1963369" y="3539486"/>
+                  <a:pt x="1897658" y="3527668"/>
+                </a:cubicBezTo>
+                <a:cubicBezTo>
+                  <a:pt x="1858723" y="3520213"/>
+                  <a:pt x="1819789" y="3518153"/>
+                  <a:pt x="1780854" y="3518637"/>
+                </a:cubicBezTo>
+                <a:cubicBezTo>
+                  <a:pt x="1741920" y="3519123"/>
+                  <a:pt x="1702985" y="3522153"/>
+                  <a:pt x="1664051" y="3524880"/>
+                </a:cubicBezTo>
+                <a:cubicBezTo>
+                  <a:pt x="1450275" y="3539790"/>
+                  <a:pt x="1236498" y="3557973"/>
+                  <a:pt x="1021996" y="3545850"/>
+                </a:cubicBezTo>
+                <a:cubicBezTo>
+                  <a:pt x="976208" y="3543304"/>
+                  <a:pt x="931564" y="3532154"/>
+                  <a:pt x="886089" y="3527546"/>
+                </a:cubicBezTo>
+                <a:cubicBezTo>
+                  <a:pt x="753918" y="3514091"/>
+                  <a:pt x="622269" y="3529851"/>
+                  <a:pt x="490410" y="3536275"/>
+                </a:cubicBezTo>
+                <a:cubicBezTo>
+                  <a:pt x="344484" y="3545511"/>
+                  <a:pt x="198194" y="3543645"/>
+                  <a:pt x="52476" y="3530699"/>
+                </a:cubicBezTo>
+                <a:lnTo>
+                  <a:pt x="16096" y="3528137"/>
+                </a:lnTo>
+                <a:lnTo>
+                  <a:pt x="13820" y="3457111"/>
+                </a:lnTo>
+                <a:cubicBezTo>
+                  <a:pt x="6425" y="3369848"/>
+                  <a:pt x="-1454" y="3282586"/>
+                  <a:pt x="8728" y="3195323"/>
+                </a:cubicBezTo>
+                <a:cubicBezTo>
+                  <a:pt x="18037" y="3120746"/>
+                  <a:pt x="19541" y="3045559"/>
+                  <a:pt x="13214" y="2970732"/>
+                </a:cubicBezTo>
+                <a:cubicBezTo>
+                  <a:pt x="6911" y="2888880"/>
+                  <a:pt x="6911" y="2806721"/>
+                  <a:pt x="13214" y="2724870"/>
+                </a:cubicBezTo>
+                <a:cubicBezTo>
+                  <a:pt x="18062" y="2646442"/>
+                  <a:pt x="26184" y="2567797"/>
+                  <a:pt x="17457" y="2489589"/>
+                </a:cubicBezTo>
+                <a:cubicBezTo>
+                  <a:pt x="5335" y="2379639"/>
+                  <a:pt x="9335" y="2270015"/>
+                  <a:pt x="16729" y="2160282"/>
+                </a:cubicBezTo>
+                <a:cubicBezTo>
+                  <a:pt x="22790" y="2069639"/>
+                  <a:pt x="31640" y="1978667"/>
+                  <a:pt x="17335" y="1888460"/>
+                </a:cubicBezTo>
+                <a:cubicBezTo>
+                  <a:pt x="159" y="1768104"/>
+                  <a:pt x="-4267" y="1646557"/>
+                  <a:pt x="4122" y="1525448"/>
+                </a:cubicBezTo>
+                <a:cubicBezTo>
+                  <a:pt x="17093" y="1276969"/>
+                  <a:pt x="13820" y="1028271"/>
+                  <a:pt x="23760" y="779682"/>
+                </a:cubicBezTo>
+                <a:cubicBezTo>
+                  <a:pt x="27153" y="697655"/>
+                  <a:pt x="8971" y="616065"/>
+                  <a:pt x="8002" y="534256"/>
+                </a:cubicBezTo>
+                <a:cubicBezTo>
+                  <a:pt x="6790" y="436250"/>
+                  <a:pt x="11124" y="337998"/>
+                  <a:pt x="14291" y="239596"/>
+                </a:cubicBezTo>
+                <a:lnTo>
+                  <a:pt x="13744" y="13183"/>
+                </a:lnTo>
+                <a:lnTo>
+                  <a:pt x="56934" y="10499"/>
+                </a:lnTo>
+                <a:cubicBezTo>
+                  <a:pt x="147688" y="3411"/>
+                  <a:pt x="238784" y="3411"/>
+                  <a:pt x="329538" y="10499"/>
+                </a:cubicBezTo>
+                <a:cubicBezTo>
+                  <a:pt x="412505" y="17614"/>
+                  <a:pt x="495870" y="15924"/>
+                  <a:pt x="578558" y="5455"/>
+                </a:cubicBezTo>
+                <a:cubicBezTo>
+                  <a:pt x="626936" y="-270"/>
+                  <a:pt x="675313" y="-917"/>
+                  <a:pt x="723689" y="906"/>
+                </a:cubicBezTo>
+                <a:close/>
+              </a:path>
+            </a:pathLst>
+          </a:custGeom>
+        </p:spPr>
+      </p:pic>
+      <p:pic>
+        <p:nvPicPr>
+          <p:cNvPr id="11" name="Imagen 10">
+            <a:extLst>
+              <a:ext uri="{FF2B5EF4-FFF2-40B4-BE49-F238E27FC236}">
+                <a16:creationId xmlns:a16="http://schemas.microsoft.com/office/drawing/2014/main" id="{0FCC98F0-A95B-B4F6-D053-5649E1CFC868}"/>
+              </a:ext>
+            </a:extLst>
+          </p:cNvPr>
+          <p:cNvPicPr>
+            <a:picLocks noChangeAspect="1"/>
+          </p:cNvPicPr>
+          <p:nvPr/>
+        </p:nvPicPr>
+        <p:blipFill>
+          <a:blip r:embed="rId5"/>
+          <a:srcRect t="11774" r="-2" b="24690"/>
+          <a:stretch>
+            <a:fillRect/>
+          </a:stretch>
+        </p:blipFill>
+        <p:spPr>
+          <a:xfrm>
+            <a:off x="8350554" y="4171427"/>
+            <a:ext cx="3434858" cy="2084130"/>
+          </a:xfrm>
+          <a:custGeom>
+            <a:avLst/>
+            <a:gdLst/>
+            <a:ahLst/>
+            <a:cxnLst/>
+            <a:rect l="l" t="t" r="r" b="b"/>
+            <a:pathLst>
+              <a:path w="3434858" h="2084130">
+                <a:moveTo>
+                  <a:pt x="1225971" y="1141"/>
+                </a:moveTo>
+                <a:cubicBezTo>
+                  <a:pt x="1283624" y="3345"/>
+                  <a:pt x="1341187" y="8746"/>
+                  <a:pt x="1398467" y="17334"/>
+                </a:cubicBezTo>
+                <a:cubicBezTo>
+                  <a:pt x="1484331" y="31639"/>
+                  <a:pt x="1570921" y="22789"/>
+                  <a:pt x="1657200" y="16728"/>
+                </a:cubicBezTo>
+                <a:cubicBezTo>
+                  <a:pt x="1761649" y="9334"/>
+                  <a:pt x="1865993" y="5334"/>
+                  <a:pt x="1970648" y="17456"/>
+                </a:cubicBezTo>
+                <a:cubicBezTo>
+                  <a:pt x="2045091" y="26183"/>
+                  <a:pt x="2119948" y="18061"/>
+                  <a:pt x="2194600" y="13213"/>
+                </a:cubicBezTo>
+                <a:cubicBezTo>
+                  <a:pt x="2272509" y="6910"/>
+                  <a:pt x="2350711" y="6910"/>
+                  <a:pt x="2428622" y="13213"/>
+                </a:cubicBezTo>
+                <a:cubicBezTo>
+                  <a:pt x="2499846" y="19540"/>
+                  <a:pt x="2571412" y="18037"/>
+                  <a:pt x="2642398" y="8727"/>
+                </a:cubicBezTo>
+                <a:cubicBezTo>
+                  <a:pt x="2725458" y="-1455"/>
+                  <a:pt x="2808518" y="6424"/>
+                  <a:pt x="2891579" y="13819"/>
+                </a:cubicBezTo>
+                <a:cubicBezTo>
+                  <a:pt x="3037765" y="27031"/>
+                  <a:pt x="3183847" y="21092"/>
+                  <a:pt x="3329721" y="11394"/>
+                </a:cubicBezTo>
+                <a:lnTo>
+                  <a:pt x="3422995" y="10092"/>
+                </a:lnTo>
+                <a:lnTo>
+                  <a:pt x="3423106" y="30386"/>
+                </a:lnTo>
+                <a:cubicBezTo>
+                  <a:pt x="3435867" y="237971"/>
+                  <a:pt x="3438238" y="446198"/>
+                  <a:pt x="3430208" y="654090"/>
+                </a:cubicBezTo>
+                <a:cubicBezTo>
+                  <a:pt x="3423106" y="827990"/>
+                  <a:pt x="3429304" y="1002474"/>
+                  <a:pt x="3417295" y="1176228"/>
+                </a:cubicBezTo>
+                <a:cubicBezTo>
+                  <a:pt x="3411355" y="1261425"/>
+                  <a:pt x="3404770" y="1348083"/>
+                  <a:pt x="3419490" y="1431526"/>
+                </a:cubicBezTo>
+                <a:cubicBezTo>
+                  <a:pt x="3444413" y="1572253"/>
+                  <a:pt x="3430724" y="1710643"/>
+                  <a:pt x="3415229" y="1849910"/>
+                </a:cubicBezTo>
+                <a:cubicBezTo>
+                  <a:pt x="3410101" y="1894678"/>
+                  <a:pt x="3408864" y="1939801"/>
+                  <a:pt x="3411481" y="1984635"/>
+                </a:cubicBezTo>
+                <a:lnTo>
+                  <a:pt x="3420281" y="2045052"/>
+                </a:lnTo>
+                <a:lnTo>
+                  <a:pt x="3334389" y="2032837"/>
+                </a:lnTo>
+                <a:cubicBezTo>
+                  <a:pt x="3297879" y="2029644"/>
+                  <a:pt x="3261227" y="2028419"/>
+                  <a:pt x="3224622" y="2029160"/>
+                </a:cubicBezTo>
+                <a:cubicBezTo>
+                  <a:pt x="3151412" y="2030641"/>
+                  <a:pt x="3078391" y="2039983"/>
+                  <a:pt x="3007079" y="2057157"/>
+                </a:cubicBezTo>
+                <a:cubicBezTo>
+                  <a:pt x="2872697" y="2088306"/>
+                  <a:pt x="2737925" y="2094750"/>
+                  <a:pt x="2602371" y="2064436"/>
+                </a:cubicBezTo>
+                <a:cubicBezTo>
+                  <a:pt x="2476389" y="2035818"/>
+                  <a:pt x="2344507" y="2037215"/>
+                  <a:pt x="2219280" y="2068494"/>
+                </a:cubicBezTo>
+                <a:cubicBezTo>
+                  <a:pt x="2186857" y="2075416"/>
+                  <a:pt x="2153821" y="2079653"/>
+                  <a:pt x="2120577" y="2081145"/>
+                </a:cubicBezTo>
+                <a:cubicBezTo>
+                  <a:pt x="1999217" y="2090573"/>
+                  <a:pt x="1879549" y="2074701"/>
+                  <a:pt x="1759622" y="2061453"/>
+                </a:cubicBezTo>
+                <a:cubicBezTo>
+                  <a:pt x="1683186" y="2052622"/>
+                  <a:pt x="1605969" y="2039136"/>
+                  <a:pt x="1530313" y="2061453"/>
+                </a:cubicBezTo>
+                <a:cubicBezTo>
+                  <a:pt x="1477590" y="2076742"/>
+                  <a:pt x="1421623" y="2080142"/>
+                  <a:pt x="1367155" y="2071358"/>
+                </a:cubicBezTo>
+                <a:cubicBezTo>
+                  <a:pt x="1270484" y="2056548"/>
+                  <a:pt x="1172107" y="2053457"/>
+                  <a:pt x="1074563" y="2062169"/>
+                </a:cubicBezTo>
+                <a:cubicBezTo>
+                  <a:pt x="1010251" y="2067921"/>
+                  <a:pt x="945429" y="2067038"/>
+                  <a:pt x="881325" y="2059543"/>
+                </a:cubicBezTo>
+                <a:cubicBezTo>
+                  <a:pt x="795121" y="2049639"/>
+                  <a:pt x="707357" y="2034243"/>
+                  <a:pt x="620895" y="2052980"/>
+                </a:cubicBezTo>
+                <a:cubicBezTo>
+                  <a:pt x="483518" y="2082816"/>
+                  <a:pt x="346272" y="2076848"/>
+                  <a:pt x="207854" y="2064914"/>
+                </a:cubicBezTo>
+                <a:cubicBezTo>
+                  <a:pt x="156354" y="2060439"/>
+                  <a:pt x="104562" y="2055725"/>
+                  <a:pt x="52622" y="2054367"/>
+                </a:cubicBezTo>
+                <a:lnTo>
+                  <a:pt x="12047" y="2054851"/>
+                </a:lnTo>
+                <a:lnTo>
+                  <a:pt x="2957" y="1815310"/>
+                </a:lnTo>
+                <a:cubicBezTo>
+                  <a:pt x="-270" y="1732929"/>
+                  <a:pt x="-1846" y="1650548"/>
+                  <a:pt x="3487" y="1568139"/>
+                </a:cubicBezTo>
+                <a:cubicBezTo>
+                  <a:pt x="12457" y="1429500"/>
+                  <a:pt x="20094" y="1290971"/>
+                  <a:pt x="12700" y="1152224"/>
+                </a:cubicBezTo>
+                <a:cubicBezTo>
+                  <a:pt x="7675" y="1076879"/>
+                  <a:pt x="5703" y="1001421"/>
+                  <a:pt x="6775" y="925999"/>
+                </a:cubicBezTo>
+                <a:lnTo>
+                  <a:pt x="11863" y="832882"/>
+                </a:lnTo>
+                <a:lnTo>
+                  <a:pt x="20970" y="766654"/>
+                </a:lnTo>
+                <a:lnTo>
+                  <a:pt x="24654" y="677192"/>
+                </a:lnTo>
+                <a:lnTo>
+                  <a:pt x="25185" y="676317"/>
+                </a:lnTo>
+                <a:lnTo>
+                  <a:pt x="25185" y="665409"/>
+                </a:lnTo>
+                <a:lnTo>
+                  <a:pt x="24741" y="664535"/>
+                </a:lnTo>
+                <a:lnTo>
+                  <a:pt x="20970" y="572951"/>
+                </a:lnTo>
+                <a:lnTo>
+                  <a:pt x="18150" y="552445"/>
+                </a:lnTo>
+                <a:lnTo>
+                  <a:pt x="15972" y="515645"/>
+                </a:lnTo>
+                <a:cubicBezTo>
+                  <a:pt x="2990" y="410624"/>
+                  <a:pt x="-416" y="304831"/>
+                  <a:pt x="5790" y="199319"/>
+                </a:cubicBezTo>
+                <a:lnTo>
+                  <a:pt x="13901" y="9025"/>
+                </a:lnTo>
+                <a:lnTo>
+                  <a:pt x="109477" y="8001"/>
+                </a:lnTo>
+                <a:cubicBezTo>
+                  <a:pt x="187346" y="8970"/>
+                  <a:pt x="265007" y="27152"/>
+                  <a:pt x="343084" y="23759"/>
+                </a:cubicBezTo>
+                <a:cubicBezTo>
+                  <a:pt x="579702" y="13819"/>
+                  <a:pt x="816423" y="17092"/>
+                  <a:pt x="1052937" y="4121"/>
+                </a:cubicBezTo>
+                <a:cubicBezTo>
+                  <a:pt x="1110576" y="-73"/>
+                  <a:pt x="1168318" y="-1064"/>
+                  <a:pt x="1225971" y="1141"/>
+                </a:cubicBezTo>
+                <a:close/>
+              </a:path>
+            </a:pathLst>
+          </a:custGeom>
+        </p:spPr>
+      </p:pic>
     </p:spTree>
     <p:extLst>
       <p:ext uri="{BB962C8B-B14F-4D97-AF65-F5344CB8AC3E}">
-        <p14:creationId xmlns:p14="http://schemas.microsoft.com/office/powerpoint/2010/main" val="762635621"/>
+        <p14:creationId xmlns:p14="http://schemas.microsoft.com/office/powerpoint/2010/main" val="826275547"/>
+      </p:ext>
+    </p:extLst>
+  </p:cSld>
+  <p:clrMapOvr>
+    <a:masterClrMapping/>
+  </p:clrMapOvr>
+</p:sld>
+</file>
+
+<file path=ppt/slides/slide7.xml><?xml version="1.0" encoding="utf-8"?>
+<p:sld xmlns:a="http://schemas.openxmlformats.org/drawingml/2006/main" xmlns:r="http://schemas.openxmlformats.org/officeDocument/2006/relationships" xmlns:p="http://schemas.openxmlformats.org/presentationml/2006/main">
+  <p:cSld>
+    <p:bg>
+      <p:bgPr>
+        <a:solidFill>
+          <a:schemeClr val="bg1"/>
+        </a:solidFill>
+        <a:effectLst/>
+      </p:bgPr>
+    </p:bg>
+    <p:spTree>
+      <p:nvGrpSpPr>
+        <p:cNvPr id="1" name=""/>
+        <p:cNvGrpSpPr/>
+        <p:nvPr/>
+      </p:nvGrpSpPr>
+      <p:grpSpPr>
+        <a:xfrm>
+          <a:off x="0" y="0"/>
+          <a:ext cx="0" cy="0"/>
+          <a:chOff x="0" y="0"/>
+          <a:chExt cx="0" cy="0"/>
+        </a:xfrm>
+      </p:grpSpPr>
+      <p:sp useBgFill="1">
+        <p:nvSpPr>
+          <p:cNvPr id="10" name="Rectangle 9">
+            <a:extLst>
+              <a:ext uri="{FF2B5EF4-FFF2-40B4-BE49-F238E27FC236}">
+                <a16:creationId xmlns:a16="http://schemas.microsoft.com/office/drawing/2014/main" id="{2B97F24A-32CE-4C1C-A50D-3016B394DCFB}"/>
+              </a:ext>
+              <a:ext uri="{C183D7F6-B498-43B3-948B-1728B52AA6E4}">
+                <adec:decorative xmlns:adec="http://schemas.microsoft.com/office/drawing/2017/decorative" val="1"/>
+              </a:ext>
+            </a:extLst>
+          </p:cNvPr>
+          <p:cNvSpPr>
+            <a:spLocks noGrp="1" noRot="1" noChangeAspect="1" noMove="1" noResize="1" noEditPoints="1" noAdjustHandles="1" noChangeArrowheads="1" noChangeShapeType="1" noTextEdit="1"/>
+          </p:cNvSpPr>
+          <p:nvPr>
+            <p:extLst>
+              <p:ext uri="{386F3935-93C4-4BCD-93E2-E3B085C9AB24}">
+                <p16:designElem xmlns:p16="http://schemas.microsoft.com/office/powerpoint/2015/main" val="1"/>
+              </p:ext>
+            </p:extLst>
+          </p:nvPr>
+        </p:nvSpPr>
+        <p:spPr>
+          <a:xfrm>
+            <a:off x="0" y="0"/>
+            <a:ext cx="12192000" cy="6858000"/>
+          </a:xfrm>
+          <a:prstGeom prst="rect">
+            <a:avLst/>
+          </a:prstGeom>
+          <a:ln>
+            <a:noFill/>
+          </a:ln>
+        </p:spPr>
+        <p:style>
+          <a:lnRef idx="2">
+            <a:schemeClr val="accent1">
+              <a:shade val="50000"/>
+            </a:schemeClr>
+          </a:lnRef>
+          <a:fillRef idx="1">
+            <a:schemeClr val="accent1"/>
+          </a:fillRef>
+          <a:effectRef idx="0">
+            <a:schemeClr val="accent1"/>
+          </a:effectRef>
+          <a:fontRef idx="minor">
+            <a:schemeClr val="lt1"/>
+          </a:fontRef>
+        </p:style>
+        <p:txBody>
+          <a:bodyPr rtlCol="0" anchor="ctr"/>
+          <a:lstStyle/>
+          <a:p>
+            <a:pPr algn="ctr"/>
+            <a:endParaRPr lang="en-US"/>
+          </a:p>
+        </p:txBody>
+      </p:sp>
+      <p:sp>
+        <p:nvSpPr>
+          <p:cNvPr id="2" name="Título 1">
+            <a:extLst>
+              <a:ext uri="{FF2B5EF4-FFF2-40B4-BE49-F238E27FC236}">
+                <a16:creationId xmlns:a16="http://schemas.microsoft.com/office/drawing/2014/main" id="{5171C725-3FFD-40F3-44F5-366FFC3DC230}"/>
+              </a:ext>
+            </a:extLst>
+          </p:cNvPr>
+          <p:cNvSpPr>
+            <a:spLocks noGrp="1"/>
+          </p:cNvSpPr>
+          <p:nvPr>
+            <p:ph type="title"/>
+          </p:nvPr>
+        </p:nvSpPr>
+        <p:spPr>
+          <a:xfrm>
+            <a:off x="630935" y="639520"/>
+            <a:ext cx="7058337" cy="771704"/>
+          </a:xfrm>
+        </p:spPr>
+        <p:txBody>
+          <a:bodyPr anchor="b">
+            <a:normAutofit fontScale="90000"/>
+          </a:bodyPr>
+          <a:lstStyle/>
+          <a:p>
+            <a:r>
+              <a:rPr lang="es-CO" sz="5400" dirty="0" err="1"/>
+              <a:t>Épica:Gestión</a:t>
+            </a:r>
+            <a:r>
+              <a:rPr lang="es-CO" sz="5400" dirty="0"/>
+              <a:t> del Catálogo</a:t>
+            </a:r>
+          </a:p>
+        </p:txBody>
+      </p:sp>
+      <p:sp>
+        <p:nvSpPr>
+          <p:cNvPr id="12" name="sketch line">
+            <a:extLst>
+              <a:ext uri="{FF2B5EF4-FFF2-40B4-BE49-F238E27FC236}">
+                <a16:creationId xmlns:a16="http://schemas.microsoft.com/office/drawing/2014/main" id="{CD8B4F24-440B-49E9-B85D-733523DC064B}"/>
+              </a:ext>
+              <a:ext uri="{C183D7F6-B498-43B3-948B-1728B52AA6E4}">
+                <adec:decorative xmlns:adec="http://schemas.microsoft.com/office/drawing/2017/decorative" val="1"/>
+              </a:ext>
+            </a:extLst>
+          </p:cNvPr>
+          <p:cNvSpPr>
+            <a:spLocks noGrp="1" noRot="1" noChangeAspect="1" noMove="1" noResize="1" noEditPoints="1" noAdjustHandles="1" noChangeArrowheads="1" noChangeShapeType="1" noTextEdit="1"/>
+          </p:cNvSpPr>
+          <p:nvPr>
+            <p:extLst>
+              <p:ext uri="{386F3935-93C4-4BCD-93E2-E3B085C9AB24}">
+                <p16:designElem xmlns:p16="http://schemas.microsoft.com/office/powerpoint/2015/main" val="1"/>
+              </p:ext>
+            </p:extLst>
+          </p:nvPr>
+        </p:nvSpPr>
+        <p:spPr>
+          <a:xfrm>
+            <a:off x="643278" y="2573756"/>
+            <a:ext cx="3255095" cy="18288"/>
+          </a:xfrm>
+          <a:custGeom>
+            <a:avLst/>
+            <a:gdLst>
+              <a:gd name="csX0" fmla="*/ 0 w 3255095"/>
+              <a:gd name="csY0" fmla="*/ 0 h 18288"/>
+              <a:gd name="csX1" fmla="*/ 618468 w 3255095"/>
+              <a:gd name="csY1" fmla="*/ 0 h 18288"/>
+              <a:gd name="csX2" fmla="*/ 1269487 w 3255095"/>
+              <a:gd name="csY2" fmla="*/ 0 h 18288"/>
+              <a:gd name="csX3" fmla="*/ 1953057 w 3255095"/>
+              <a:gd name="csY3" fmla="*/ 0 h 18288"/>
+              <a:gd name="csX4" fmla="*/ 2636627 w 3255095"/>
+              <a:gd name="csY4" fmla="*/ 0 h 18288"/>
+              <a:gd name="csX5" fmla="*/ 3255095 w 3255095"/>
+              <a:gd name="csY5" fmla="*/ 0 h 18288"/>
+              <a:gd name="csX6" fmla="*/ 3255095 w 3255095"/>
+              <a:gd name="csY6" fmla="*/ 18288 h 18288"/>
+              <a:gd name="csX7" fmla="*/ 2538974 w 3255095"/>
+              <a:gd name="csY7" fmla="*/ 18288 h 18288"/>
+              <a:gd name="csX8" fmla="*/ 1822853 w 3255095"/>
+              <a:gd name="csY8" fmla="*/ 18288 h 18288"/>
+              <a:gd name="csX9" fmla="*/ 1171834 w 3255095"/>
+              <a:gd name="csY9" fmla="*/ 18288 h 18288"/>
+              <a:gd name="csX10" fmla="*/ 0 w 3255095"/>
+              <a:gd name="csY10" fmla="*/ 18288 h 18288"/>
+              <a:gd name="csX11" fmla="*/ 0 w 3255095"/>
+              <a:gd name="csY11" fmla="*/ 0 h 18288"/>
+            </a:gdLst>
+            <a:ahLst/>
+            <a:cxnLst>
+              <a:cxn ang="0">
+                <a:pos x="csX0" y="csY0"/>
+              </a:cxn>
+              <a:cxn ang="0">
+                <a:pos x="csX1" y="csY1"/>
+              </a:cxn>
+              <a:cxn ang="0">
+                <a:pos x="csX2" y="csY2"/>
+              </a:cxn>
+              <a:cxn ang="0">
+                <a:pos x="csX3" y="csY3"/>
+              </a:cxn>
+              <a:cxn ang="0">
+                <a:pos x="csX4" y="csY4"/>
+              </a:cxn>
+              <a:cxn ang="0">
+                <a:pos x="csX5" y="csY5"/>
+              </a:cxn>
+              <a:cxn ang="0">
+                <a:pos x="csX6" y="csY6"/>
+              </a:cxn>
+              <a:cxn ang="0">
+                <a:pos x="csX7" y="csY7"/>
+              </a:cxn>
+              <a:cxn ang="0">
+                <a:pos x="csX8" y="csY8"/>
+              </a:cxn>
+              <a:cxn ang="0">
+                <a:pos x="csX9" y="csY9"/>
+              </a:cxn>
+              <a:cxn ang="0">
+                <a:pos x="csX10" y="csY10"/>
+              </a:cxn>
+              <a:cxn ang="0">
+                <a:pos x="csX11" y="csY11"/>
+              </a:cxn>
+            </a:cxnLst>
+            <a:rect l="l" t="t" r="r" b="b"/>
+            <a:pathLst>
+              <a:path w="3255095" h="18288" fill="none" extrusionOk="0">
+                <a:moveTo>
+                  <a:pt x="0" y="0"/>
+                </a:moveTo>
+                <a:cubicBezTo>
+                  <a:pt x="240201" y="-22123"/>
+                  <a:pt x="462021" y="-19623"/>
+                  <a:pt x="618468" y="0"/>
+                </a:cubicBezTo>
+                <a:cubicBezTo>
+                  <a:pt x="774915" y="19623"/>
+                  <a:pt x="974734" y="2035"/>
+                  <a:pt x="1269487" y="0"/>
+                </a:cubicBezTo>
+                <a:cubicBezTo>
+                  <a:pt x="1564240" y="-2035"/>
+                  <a:pt x="1733579" y="10639"/>
+                  <a:pt x="1953057" y="0"/>
+                </a:cubicBezTo>
+                <a:cubicBezTo>
+                  <a:pt x="2172535" y="-10639"/>
+                  <a:pt x="2453962" y="14018"/>
+                  <a:pt x="2636627" y="0"/>
+                </a:cubicBezTo>
+                <a:cubicBezTo>
+                  <a:pt x="2819292" y="-14018"/>
+                  <a:pt x="3121375" y="5399"/>
+                  <a:pt x="3255095" y="0"/>
+                </a:cubicBezTo>
+                <a:cubicBezTo>
+                  <a:pt x="3254386" y="8157"/>
+                  <a:pt x="3254682" y="12125"/>
+                  <a:pt x="3255095" y="18288"/>
+                </a:cubicBezTo>
+                <a:cubicBezTo>
+                  <a:pt x="3088545" y="23203"/>
+                  <a:pt x="2687475" y="7419"/>
+                  <a:pt x="2538974" y="18288"/>
+                </a:cubicBezTo>
+                <a:cubicBezTo>
+                  <a:pt x="2390473" y="29157"/>
+                  <a:pt x="2137381" y="-8959"/>
+                  <a:pt x="1822853" y="18288"/>
+                </a:cubicBezTo>
+                <a:cubicBezTo>
+                  <a:pt x="1508325" y="45535"/>
+                  <a:pt x="1466437" y="20385"/>
+                  <a:pt x="1171834" y="18288"/>
+                </a:cubicBezTo>
+                <a:cubicBezTo>
+                  <a:pt x="877231" y="16191"/>
+                  <a:pt x="561097" y="37643"/>
+                  <a:pt x="0" y="18288"/>
+                </a:cubicBezTo>
+                <a:cubicBezTo>
+                  <a:pt x="-46" y="12483"/>
+                  <a:pt x="-203" y="6491"/>
+                  <a:pt x="0" y="0"/>
+                </a:cubicBezTo>
+                <a:close/>
+              </a:path>
+              <a:path w="3255095" h="18288" stroke="0" extrusionOk="0">
+                <a:moveTo>
+                  <a:pt x="0" y="0"/>
+                </a:moveTo>
+                <a:cubicBezTo>
+                  <a:pt x="291965" y="19429"/>
+                  <a:pt x="363155" y="8568"/>
+                  <a:pt x="618468" y="0"/>
+                </a:cubicBezTo>
+                <a:cubicBezTo>
+                  <a:pt x="873781" y="-8568"/>
+                  <a:pt x="904459" y="-19505"/>
+                  <a:pt x="1171834" y="0"/>
+                </a:cubicBezTo>
+                <a:cubicBezTo>
+                  <a:pt x="1439209" y="19505"/>
+                  <a:pt x="1744369" y="9790"/>
+                  <a:pt x="1887955" y="0"/>
+                </a:cubicBezTo>
+                <a:cubicBezTo>
+                  <a:pt x="2031541" y="-9790"/>
+                  <a:pt x="2346378" y="21240"/>
+                  <a:pt x="2506423" y="0"/>
+                </a:cubicBezTo>
+                <a:cubicBezTo>
+                  <a:pt x="2666468" y="-21240"/>
+                  <a:pt x="2990257" y="30414"/>
+                  <a:pt x="3255095" y="0"/>
+                </a:cubicBezTo>
+                <a:cubicBezTo>
+                  <a:pt x="3254831" y="4493"/>
+                  <a:pt x="3255479" y="9472"/>
+                  <a:pt x="3255095" y="18288"/>
+                </a:cubicBezTo>
+                <a:cubicBezTo>
+                  <a:pt x="3120743" y="16690"/>
+                  <a:pt x="2759628" y="42462"/>
+                  <a:pt x="2604076" y="18288"/>
+                </a:cubicBezTo>
+                <a:cubicBezTo>
+                  <a:pt x="2448524" y="-5886"/>
+                  <a:pt x="2184336" y="19599"/>
+                  <a:pt x="1887955" y="18288"/>
+                </a:cubicBezTo>
+                <a:cubicBezTo>
+                  <a:pt x="1591574" y="16977"/>
+                  <a:pt x="1548845" y="6870"/>
+                  <a:pt x="1334589" y="18288"/>
+                </a:cubicBezTo>
+                <a:cubicBezTo>
+                  <a:pt x="1120333" y="29706"/>
+                  <a:pt x="996014" y="9662"/>
+                  <a:pt x="683570" y="18288"/>
+                </a:cubicBezTo>
+                <a:cubicBezTo>
+                  <a:pt x="371126" y="26914"/>
+                  <a:pt x="198687" y="16167"/>
+                  <a:pt x="0" y="18288"/>
+                </a:cubicBezTo>
+                <a:cubicBezTo>
+                  <a:pt x="843" y="9577"/>
+                  <a:pt x="371" y="6900"/>
+                  <a:pt x="0" y="0"/>
+                </a:cubicBezTo>
+                <a:close/>
+              </a:path>
+            </a:pathLst>
+          </a:custGeom>
+          <a:solidFill>
+            <a:schemeClr val="accent2"/>
+          </a:solidFill>
+          <a:ln w="38100" cap="rnd">
+            <a:solidFill>
+              <a:schemeClr val="accent2"/>
+            </a:solidFill>
+            <a:round/>
+            <a:extLst>
+              <a:ext uri="{C807C97D-BFC1-408E-A445-0C87EB9F89A2}">
+                <ask:lineSketchStyleProps xmlns:ask="http://schemas.microsoft.com/office/drawing/2018/sketchyshapes" sd="1219033472">
+                  <a:prstGeom prst="rect">
+                    <a:avLst/>
+                  </a:prstGeom>
+                  <ask:type>
+                    <ask:lineSketchFreehand/>
+                  </ask:type>
+                </ask:lineSketchStyleProps>
+              </a:ext>
+            </a:extLst>
+          </a:ln>
+        </p:spPr>
+        <p:style>
+          <a:lnRef idx="2">
+            <a:schemeClr val="accent1">
+              <a:shade val="50000"/>
+            </a:schemeClr>
+          </a:lnRef>
+          <a:fillRef idx="1">
+            <a:schemeClr val="accent1"/>
+          </a:fillRef>
+          <a:effectRef idx="0">
+            <a:schemeClr val="accent1"/>
+          </a:effectRef>
+          <a:fontRef idx="minor">
+            <a:schemeClr val="lt1"/>
+          </a:fontRef>
+        </p:style>
+        <p:txBody>
+          <a:bodyPr rtlCol="0" anchor="ctr"/>
+          <a:lstStyle/>
+          <a:p>
+            <a:pPr algn="ctr"/>
+            <a:endParaRPr lang="en-US"/>
+          </a:p>
+        </p:txBody>
+      </p:sp>
+      <p:sp>
+        <p:nvSpPr>
+          <p:cNvPr id="3" name="Marcador de contenido 2">
+            <a:extLst>
+              <a:ext uri="{FF2B5EF4-FFF2-40B4-BE49-F238E27FC236}">
+                <a16:creationId xmlns:a16="http://schemas.microsoft.com/office/drawing/2014/main" id="{149B451A-2BB9-BE65-2ED3-37DE6E252E9B}"/>
+              </a:ext>
+            </a:extLst>
+          </p:cNvPr>
+          <p:cNvSpPr>
+            <a:spLocks noGrp="1"/>
+          </p:cNvSpPr>
+          <p:nvPr>
+            <p:ph idx="1"/>
+          </p:nvPr>
+        </p:nvSpPr>
+        <p:spPr>
+          <a:xfrm>
+            <a:off x="731103" y="1560016"/>
+            <a:ext cx="3429000" cy="490728"/>
+          </a:xfrm>
+        </p:spPr>
+        <p:txBody>
+          <a:bodyPr anchor="t">
+            <a:normAutofit/>
+          </a:bodyPr>
+          <a:lstStyle/>
+          <a:p>
+            <a:r>
+              <a:rPr lang="es-CO" sz="2200" dirty="0"/>
+              <a:t>Historias de usuario:</a:t>
+            </a:r>
+          </a:p>
+          <a:p>
+            <a:endParaRPr lang="es-CO" sz="2200" dirty="0"/>
+          </a:p>
+          <a:p>
+            <a:endParaRPr lang="es-CO" sz="2200" dirty="0"/>
+          </a:p>
+          <a:p>
+            <a:endParaRPr lang="es-CO" sz="2200" dirty="0"/>
+          </a:p>
+        </p:txBody>
+      </p:sp>
+      <p:graphicFrame>
+        <p:nvGraphicFramePr>
+          <p:cNvPr id="5" name="Tabla 4">
+            <a:extLst>
+              <a:ext uri="{FF2B5EF4-FFF2-40B4-BE49-F238E27FC236}">
+                <a16:creationId xmlns:a16="http://schemas.microsoft.com/office/drawing/2014/main" id="{2A564A36-1681-540F-9631-91D47839C67E}"/>
+              </a:ext>
+            </a:extLst>
+          </p:cNvPr>
+          <p:cNvGraphicFramePr>
+            <a:graphicFrameLocks noGrp="1"/>
+          </p:cNvGraphicFramePr>
+          <p:nvPr>
+            <p:extLst>
+              <p:ext uri="{D42A27DB-BD31-4B8C-83A1-F6EECF244321}">
+                <p14:modId xmlns:p14="http://schemas.microsoft.com/office/powerpoint/2010/main" val="3857964466"/>
+              </p:ext>
+            </p:extLst>
+          </p:nvPr>
+        </p:nvGraphicFramePr>
+        <p:xfrm>
+          <a:off x="1607126" y="2751801"/>
+          <a:ext cx="8804565" cy="3466679"/>
+        </p:xfrm>
+        <a:graphic>
+          <a:graphicData uri="http://schemas.openxmlformats.org/drawingml/2006/table">
+            <a:tbl>
+              <a:tblPr firstRow="1" bandRow="1">
+                <a:tableStyleId>{5C22544A-7EE6-4342-B048-85BDC9FD1C3A}</a:tableStyleId>
+              </a:tblPr>
+              <a:tblGrid>
+                <a:gridCol w="1605211">
+                  <a:extLst>
+                    <a:ext uri="{9D8B030D-6E8A-4147-A177-3AD203B41FA5}">
+                      <a16:colId xmlns:a16="http://schemas.microsoft.com/office/drawing/2014/main" val="3184512264"/>
+                    </a:ext>
+                  </a:extLst>
+                </a:gridCol>
+                <a:gridCol w="1605211">
+                  <a:extLst>
+                    <a:ext uri="{9D8B030D-6E8A-4147-A177-3AD203B41FA5}">
+                      <a16:colId xmlns:a16="http://schemas.microsoft.com/office/drawing/2014/main" val="581056201"/>
+                    </a:ext>
+                  </a:extLst>
+                </a:gridCol>
+                <a:gridCol w="3034357">
+                  <a:extLst>
+                    <a:ext uri="{9D8B030D-6E8A-4147-A177-3AD203B41FA5}">
+                      <a16:colId xmlns:a16="http://schemas.microsoft.com/office/drawing/2014/main" val="2692977075"/>
+                    </a:ext>
+                  </a:extLst>
+                </a:gridCol>
+                <a:gridCol w="2559786">
+                  <a:extLst>
+                    <a:ext uri="{9D8B030D-6E8A-4147-A177-3AD203B41FA5}">
+                      <a16:colId xmlns:a16="http://schemas.microsoft.com/office/drawing/2014/main" val="1362305337"/>
+                    </a:ext>
+                  </a:extLst>
+                </a:gridCol>
+              </a:tblGrid>
+              <a:tr h="648410">
+                <a:tc>
+                  <a:txBody>
+                    <a:bodyPr/>
+                    <a:lstStyle/>
+                    <a:p>
+                      <a:pPr rtl="0" fontAlgn="b">
+                        <a:buNone/>
+                      </a:pPr>
+                      <a:r>
+                        <a:rPr lang="es-CO" sz="1600">
+                          <a:effectLst/>
+                          <a:latin typeface="Arial" panose="020B0604020202020204" pitchFamily="34" charset="0"/>
+                        </a:rPr>
+                        <a:t>identificador(ID) de la historia</a:t>
+                      </a:r>
+                    </a:p>
+                  </a:txBody>
+                  <a:tcPr marL="14288" marR="14288" marT="9525" marB="9525" anchor="b"/>
+                </a:tc>
+                <a:tc>
+                  <a:txBody>
+                    <a:bodyPr/>
+                    <a:lstStyle/>
+                    <a:p>
+                      <a:pPr rtl="0" fontAlgn="b">
+                        <a:buNone/>
+                      </a:pPr>
+                      <a:r>
+                        <a:rPr lang="es-CO" sz="1600" dirty="0">
+                          <a:effectLst/>
+                        </a:rPr>
+                        <a:t>ROL</a:t>
+                      </a:r>
+                      <a:endParaRPr lang="es-CO" sz="1600" dirty="0">
+                        <a:effectLst/>
+                        <a:latin typeface="Arial" panose="020B0604020202020204" pitchFamily="34" charset="0"/>
+                      </a:endParaRPr>
+                    </a:p>
+                  </a:txBody>
+                  <a:tcPr marL="15633" marR="15633" marT="10422" marB="10422" anchor="b"/>
+                </a:tc>
+                <a:tc>
+                  <a:txBody>
+                    <a:bodyPr/>
+                    <a:lstStyle/>
+                    <a:p>
+                      <a:pPr rtl="0" fontAlgn="b">
+                        <a:buNone/>
+                      </a:pPr>
+                      <a:r>
+                        <a:rPr lang="es-CO" sz="1600">
+                          <a:effectLst/>
+                        </a:rPr>
+                        <a:t>Característica/funcionalidad (Quiero)</a:t>
+                      </a:r>
+                      <a:endParaRPr lang="es-CO" sz="1600">
+                        <a:effectLst/>
+                        <a:latin typeface="Arial" panose="020B0604020202020204" pitchFamily="34" charset="0"/>
+                      </a:endParaRPr>
+                    </a:p>
+                  </a:txBody>
+                  <a:tcPr marL="15633" marR="15633" marT="10422" marB="10422" anchor="b"/>
+                </a:tc>
+                <a:tc>
+                  <a:txBody>
+                    <a:bodyPr/>
+                    <a:lstStyle/>
+                    <a:p>
+                      <a:pPr rtl="0" fontAlgn="b">
+                        <a:buNone/>
+                      </a:pPr>
+                      <a:r>
+                        <a:rPr lang="es-CO" sz="1600" dirty="0">
+                          <a:effectLst/>
+                        </a:rPr>
+                        <a:t>Razón/Resultado (Para)</a:t>
+                      </a:r>
+                      <a:endParaRPr lang="es-CO" sz="1600" dirty="0">
+                        <a:effectLst/>
+                        <a:latin typeface="Arial" panose="020B0604020202020204" pitchFamily="34" charset="0"/>
+                      </a:endParaRPr>
+                    </a:p>
+                  </a:txBody>
+                  <a:tcPr marL="15633" marR="15633" marT="10422" marB="10422" anchor="b"/>
+                </a:tc>
+                <a:extLst>
+                  <a:ext uri="{0D108BD9-81ED-4DB2-BD59-A6C34878D82A}">
+                    <a16:rowId xmlns:a16="http://schemas.microsoft.com/office/drawing/2014/main" val="444143429"/>
+                  </a:ext>
+                </a:extLst>
+              </a:tr>
+              <a:tr h="939423">
+                <a:tc>
+                  <a:txBody>
+                    <a:bodyPr/>
+                    <a:lstStyle/>
+                    <a:p>
+                      <a:pPr rtl="0" fontAlgn="b">
+                        <a:buNone/>
+                      </a:pPr>
+                      <a:r>
+                        <a:rPr lang="es-CO" sz="1600" dirty="0">
+                          <a:effectLst/>
+                          <a:latin typeface="Arial" panose="020B0604020202020204" pitchFamily="34" charset="0"/>
+                        </a:rPr>
+                        <a:t>HE1-HU1-CA001</a:t>
+                      </a:r>
+                    </a:p>
+                  </a:txBody>
+                  <a:tcPr marL="14288" marR="14288" marT="9525" marB="9525" anchor="b"/>
+                </a:tc>
+                <a:tc>
+                  <a:txBody>
+                    <a:bodyPr/>
+                    <a:lstStyle/>
+                    <a:p>
+                      <a:pPr algn="ctr" rtl="0" fontAlgn="b">
+                        <a:buNone/>
+                      </a:pPr>
+                      <a:r>
+                        <a:rPr lang="es-CO" sz="1600" dirty="0">
+                          <a:effectLst/>
+                        </a:rPr>
+                        <a:t>Administrador</a:t>
+                      </a:r>
+                      <a:endParaRPr lang="es-CO" sz="1600" dirty="0">
+                        <a:effectLst/>
+                        <a:latin typeface="Arial" panose="020B0604020202020204" pitchFamily="34" charset="0"/>
+                      </a:endParaRPr>
+                    </a:p>
+                  </a:txBody>
+                  <a:tcPr marL="15633" marR="15633" marT="10422" marB="10422" anchor="b"/>
+                </a:tc>
+                <a:tc>
+                  <a:txBody>
+                    <a:bodyPr/>
+                    <a:lstStyle/>
+                    <a:p>
+                      <a:pPr rtl="0" fontAlgn="b">
+                        <a:buNone/>
+                      </a:pPr>
+                      <a:r>
+                        <a:rPr lang="es-CO" sz="1600">
+                          <a:effectLst/>
+                        </a:rPr>
+                        <a:t>Registrar un nuevo producto</a:t>
+                      </a:r>
+                      <a:endParaRPr lang="es-CO" sz="1600" b="0">
+                        <a:effectLst/>
+                        <a:latin typeface="Aptos Narrow" panose="020B0004020202020204" pitchFamily="34" charset="0"/>
+                      </a:endParaRPr>
+                    </a:p>
+                  </a:txBody>
+                  <a:tcPr marL="15633" marR="15633" marT="10422" marB="10422" anchor="b"/>
+                </a:tc>
+                <a:tc>
+                  <a:txBody>
+                    <a:bodyPr/>
+                    <a:lstStyle/>
+                    <a:p>
+                      <a:pPr rtl="0" fontAlgn="b">
+                        <a:buNone/>
+                      </a:pPr>
+                      <a:r>
+                        <a:rPr lang="es-CO" sz="1600" dirty="0">
+                          <a:effectLst/>
+                        </a:rPr>
+                        <a:t>Publicar joyas y perfumes en la tienda virtual</a:t>
+                      </a:r>
+                      <a:endParaRPr lang="es-CO" sz="1600" b="0" dirty="0">
+                        <a:effectLst/>
+                        <a:latin typeface="Aptos Narrow" panose="020B0004020202020204" pitchFamily="34" charset="0"/>
+                      </a:endParaRPr>
+                    </a:p>
+                  </a:txBody>
+                  <a:tcPr marL="15633" marR="15633" marT="10422" marB="10422" anchor="b"/>
+                </a:tc>
+                <a:extLst>
+                  <a:ext uri="{0D108BD9-81ED-4DB2-BD59-A6C34878D82A}">
+                    <a16:rowId xmlns:a16="http://schemas.microsoft.com/office/drawing/2014/main" val="1785084388"/>
+                  </a:ext>
+                </a:extLst>
+              </a:tr>
+              <a:tr h="939423">
+                <a:tc>
+                  <a:txBody>
+                    <a:bodyPr/>
+                    <a:lstStyle/>
+                    <a:p>
+                      <a:pPr rtl="0" fontAlgn="b">
+                        <a:buNone/>
+                      </a:pPr>
+                      <a:r>
+                        <a:rPr lang="es-CO" sz="1600" dirty="0">
+                          <a:effectLst/>
+                          <a:latin typeface="Arial" panose="020B0604020202020204" pitchFamily="34" charset="0"/>
+                        </a:rPr>
+                        <a:t>HE1-HU2-CA002</a:t>
+                      </a:r>
+                    </a:p>
+                  </a:txBody>
+                  <a:tcPr marL="14288" marR="14288" marT="9525" marB="9525" anchor="b"/>
+                </a:tc>
+                <a:tc>
+                  <a:txBody>
+                    <a:bodyPr/>
+                    <a:lstStyle/>
+                    <a:p>
+                      <a:pPr algn="ctr" rtl="0" fontAlgn="b">
+                        <a:buNone/>
+                      </a:pPr>
+                      <a:r>
+                        <a:rPr lang="es-CO" sz="1600" dirty="0">
+                          <a:effectLst/>
+                        </a:rPr>
+                        <a:t>Administrador</a:t>
+                      </a:r>
+                      <a:endParaRPr lang="es-CO" sz="1600" dirty="0">
+                        <a:effectLst/>
+                        <a:latin typeface="Arial" panose="020B0604020202020204" pitchFamily="34" charset="0"/>
+                      </a:endParaRPr>
+                    </a:p>
+                  </a:txBody>
+                  <a:tcPr marL="15633" marR="15633" marT="10422" marB="10422" anchor="b"/>
+                </a:tc>
+                <a:tc>
+                  <a:txBody>
+                    <a:bodyPr/>
+                    <a:lstStyle/>
+                    <a:p>
+                      <a:pPr rtl="0" fontAlgn="b">
+                        <a:buNone/>
+                      </a:pPr>
+                      <a:r>
+                        <a:rPr lang="es-CO" sz="1600">
+                          <a:effectLst/>
+                        </a:rPr>
+                        <a:t>Modificar datos de productos</a:t>
+                      </a:r>
+                      <a:endParaRPr lang="es-CO" sz="1600" b="0">
+                        <a:effectLst/>
+                        <a:latin typeface="Aptos Narrow" panose="020B0004020202020204" pitchFamily="34" charset="0"/>
+                      </a:endParaRPr>
+                    </a:p>
+                  </a:txBody>
+                  <a:tcPr marL="15633" marR="15633" marT="10422" marB="10422" anchor="b"/>
+                </a:tc>
+                <a:tc>
+                  <a:txBody>
+                    <a:bodyPr/>
+                    <a:lstStyle/>
+                    <a:p>
+                      <a:pPr rtl="0" fontAlgn="b">
+                        <a:buNone/>
+                      </a:pPr>
+                      <a:r>
+                        <a:rPr lang="es-CO" sz="1600">
+                          <a:effectLst/>
+                        </a:rPr>
+                        <a:t>Actualizar precios, descripciones o cantidades en stock</a:t>
+                      </a:r>
+                      <a:endParaRPr lang="es-CO" sz="1600" b="0">
+                        <a:effectLst/>
+                        <a:latin typeface="Aptos Narrow" panose="020B0004020202020204" pitchFamily="34" charset="0"/>
+                      </a:endParaRPr>
+                    </a:p>
+                  </a:txBody>
+                  <a:tcPr marL="15633" marR="15633" marT="10422" marB="10422" anchor="b"/>
+                </a:tc>
+                <a:extLst>
+                  <a:ext uri="{0D108BD9-81ED-4DB2-BD59-A6C34878D82A}">
+                    <a16:rowId xmlns:a16="http://schemas.microsoft.com/office/drawing/2014/main" val="1521883676"/>
+                  </a:ext>
+                </a:extLst>
+              </a:tr>
+              <a:tr h="939423">
+                <a:tc>
+                  <a:txBody>
+                    <a:bodyPr/>
+                    <a:lstStyle/>
+                    <a:p>
+                      <a:pPr rtl="0" fontAlgn="b">
+                        <a:buNone/>
+                      </a:pPr>
+                      <a:r>
+                        <a:rPr lang="es-CO" sz="1600" dirty="0">
+                          <a:effectLst/>
+                          <a:latin typeface="Arial" panose="020B0604020202020204" pitchFamily="34" charset="0"/>
+                        </a:rPr>
+                        <a:t>HE1-HU3-CA003</a:t>
+                      </a:r>
+                    </a:p>
+                  </a:txBody>
+                  <a:tcPr marL="14288" marR="14288" marT="9525" marB="9525" anchor="b"/>
+                </a:tc>
+                <a:tc>
+                  <a:txBody>
+                    <a:bodyPr/>
+                    <a:lstStyle/>
+                    <a:p>
+                      <a:pPr algn="ctr" rtl="0" fontAlgn="b">
+                        <a:buNone/>
+                      </a:pPr>
+                      <a:r>
+                        <a:rPr lang="es-CO" sz="1600" dirty="0">
+                          <a:effectLst/>
+                        </a:rPr>
+                        <a:t>Cliente</a:t>
+                      </a:r>
+                      <a:endParaRPr lang="es-CO" sz="1600" b="0" dirty="0">
+                        <a:effectLst/>
+                        <a:latin typeface="Aptos Narrow" panose="020B0004020202020204" pitchFamily="34" charset="0"/>
+                      </a:endParaRPr>
+                    </a:p>
+                  </a:txBody>
+                  <a:tcPr marL="15633" marR="15633" marT="10422" marB="10422" anchor="b"/>
+                </a:tc>
+                <a:tc>
+                  <a:txBody>
+                    <a:bodyPr/>
+                    <a:lstStyle/>
+                    <a:p>
+                      <a:pPr rtl="0" fontAlgn="b">
+                        <a:buNone/>
+                      </a:pPr>
+                      <a:r>
+                        <a:rPr lang="es-CO" sz="1600">
+                          <a:effectLst/>
+                        </a:rPr>
+                        <a:t>Consultar el cátalogo interactivo</a:t>
+                      </a:r>
+                      <a:endParaRPr lang="es-CO" sz="1600">
+                        <a:effectLst/>
+                        <a:latin typeface="Arial" panose="020B0604020202020204" pitchFamily="34" charset="0"/>
+                      </a:endParaRPr>
+                    </a:p>
+                  </a:txBody>
+                  <a:tcPr marL="15633" marR="15633" marT="10422" marB="10422" anchor="b"/>
+                </a:tc>
+                <a:tc>
+                  <a:txBody>
+                    <a:bodyPr/>
+                    <a:lstStyle/>
+                    <a:p>
+                      <a:pPr rtl="0" fontAlgn="b">
+                        <a:buNone/>
+                      </a:pPr>
+                      <a:r>
+                        <a:rPr lang="es-CO" sz="1600" dirty="0">
+                          <a:effectLst/>
+                        </a:rPr>
+                        <a:t>Explorar productos con sus imágenes, detalles y precios</a:t>
+                      </a:r>
+                      <a:endParaRPr lang="es-CO" sz="1600" dirty="0">
+                        <a:effectLst/>
+                        <a:latin typeface="Arial" panose="020B0604020202020204" pitchFamily="34" charset="0"/>
+                      </a:endParaRPr>
+                    </a:p>
+                  </a:txBody>
+                  <a:tcPr marL="15633" marR="15633" marT="10422" marB="10422" anchor="b"/>
+                </a:tc>
+                <a:extLst>
+                  <a:ext uri="{0D108BD9-81ED-4DB2-BD59-A6C34878D82A}">
+                    <a16:rowId xmlns:a16="http://schemas.microsoft.com/office/drawing/2014/main" val="2196993373"/>
+                  </a:ext>
+                </a:extLst>
+              </a:tr>
+            </a:tbl>
+          </a:graphicData>
+        </a:graphic>
+      </p:graphicFrame>
+    </p:spTree>
+    <p:extLst>
+      <p:ext uri="{BB962C8B-B14F-4D97-AF65-F5344CB8AC3E}">
+        <p14:creationId xmlns:p14="http://schemas.microsoft.com/office/powerpoint/2010/main" val="2526403144"/>
+      </p:ext>
+    </p:extLst>
+  </p:cSld>
+  <p:clrMapOvr>
+    <a:masterClrMapping/>
+  </p:clrMapOvr>
+</p:sld>
+</file>
+
+<file path=ppt/slides/slide8.xml><?xml version="1.0" encoding="utf-8"?>
+<p:sld xmlns:a="http://schemas.openxmlformats.org/drawingml/2006/main" xmlns:r="http://schemas.openxmlformats.org/officeDocument/2006/relationships" xmlns:p="http://schemas.openxmlformats.org/presentationml/2006/main">
+  <p:cSld>
+    <p:spTree>
+      <p:nvGrpSpPr>
+        <p:cNvPr id="1" name=""/>
+        <p:cNvGrpSpPr/>
+        <p:nvPr/>
+      </p:nvGrpSpPr>
+      <p:grpSpPr>
+        <a:xfrm>
+          <a:off x="0" y="0"/>
+          <a:ext cx="0" cy="0"/>
+          <a:chOff x="0" y="0"/>
+          <a:chExt cx="0" cy="0"/>
+        </a:xfrm>
+      </p:grpSpPr>
+      <p:sp>
+        <p:nvSpPr>
+          <p:cNvPr id="2" name="Título 1">
+            <a:extLst>
+              <a:ext uri="{FF2B5EF4-FFF2-40B4-BE49-F238E27FC236}">
+                <a16:creationId xmlns:a16="http://schemas.microsoft.com/office/drawing/2014/main" id="{1A930660-ADF4-E0AA-9354-CC0B520E8CF9}"/>
+              </a:ext>
+            </a:extLst>
+          </p:cNvPr>
+          <p:cNvSpPr>
+            <a:spLocks noGrp="1"/>
+          </p:cNvSpPr>
+          <p:nvPr>
+            <p:ph type="title"/>
+          </p:nvPr>
+        </p:nvSpPr>
+        <p:spPr/>
+        <p:txBody>
+          <a:bodyPr/>
+          <a:lstStyle/>
+          <a:p>
+            <a:r>
+              <a:rPr lang="es-CO" dirty="0"/>
+              <a:t>Estimación Poker épica : Gestión del Catálogo</a:t>
+            </a:r>
+          </a:p>
+        </p:txBody>
+      </p:sp>
+      <p:graphicFrame>
+        <p:nvGraphicFramePr>
+          <p:cNvPr id="4" name="Tabla 3">
+            <a:extLst>
+              <a:ext uri="{FF2B5EF4-FFF2-40B4-BE49-F238E27FC236}">
+                <a16:creationId xmlns:a16="http://schemas.microsoft.com/office/drawing/2014/main" id="{A043AA19-C06A-B37B-ED12-D1909A3A593A}"/>
+              </a:ext>
+            </a:extLst>
+          </p:cNvPr>
+          <p:cNvGraphicFramePr>
+            <a:graphicFrameLocks noGrp="1"/>
+          </p:cNvGraphicFramePr>
+          <p:nvPr>
+            <p:extLst>
+              <p:ext uri="{D42A27DB-BD31-4B8C-83A1-F6EECF244321}">
+                <p14:modId xmlns:p14="http://schemas.microsoft.com/office/powerpoint/2010/main" val="1712186320"/>
+              </p:ext>
+            </p:extLst>
+          </p:nvPr>
+        </p:nvGraphicFramePr>
+        <p:xfrm>
+          <a:off x="243281" y="1930231"/>
+          <a:ext cx="11761365" cy="4571468"/>
+        </p:xfrm>
+        <a:graphic>
+          <a:graphicData uri="http://schemas.openxmlformats.org/drawingml/2006/table">
+            <a:tbl>
+              <a:tblPr>
+                <a:tableStyleId>{5C22544A-7EE6-4342-B048-85BDC9FD1C3A}</a:tableStyleId>
+              </a:tblPr>
+              <a:tblGrid>
+                <a:gridCol w="1141449">
+                  <a:extLst>
+                    <a:ext uri="{9D8B030D-6E8A-4147-A177-3AD203B41FA5}">
+                      <a16:colId xmlns:a16="http://schemas.microsoft.com/office/drawing/2014/main" val="1433472951"/>
+                    </a:ext>
+                  </a:extLst>
+                </a:gridCol>
+                <a:gridCol w="980965">
+                  <a:extLst>
+                    <a:ext uri="{9D8B030D-6E8A-4147-A177-3AD203B41FA5}">
+                      <a16:colId xmlns:a16="http://schemas.microsoft.com/office/drawing/2014/main" val="2518959707"/>
+                    </a:ext>
+                  </a:extLst>
+                </a:gridCol>
+                <a:gridCol w="956345">
+                  <a:extLst>
+                    <a:ext uri="{9D8B030D-6E8A-4147-A177-3AD203B41FA5}">
+                      <a16:colId xmlns:a16="http://schemas.microsoft.com/office/drawing/2014/main" val="3095718377"/>
+                    </a:ext>
+                  </a:extLst>
+                </a:gridCol>
+                <a:gridCol w="961832">
+                  <a:extLst>
+                    <a:ext uri="{9D8B030D-6E8A-4147-A177-3AD203B41FA5}">
+                      <a16:colId xmlns:a16="http://schemas.microsoft.com/office/drawing/2014/main" val="2659580985"/>
+                    </a:ext>
+                  </a:extLst>
+                </a:gridCol>
+                <a:gridCol w="1059915">
+                  <a:extLst>
+                    <a:ext uri="{9D8B030D-6E8A-4147-A177-3AD203B41FA5}">
+                      <a16:colId xmlns:a16="http://schemas.microsoft.com/office/drawing/2014/main" val="1498535882"/>
+                    </a:ext>
+                  </a:extLst>
+                </a:gridCol>
+                <a:gridCol w="1115736">
+                  <a:extLst>
+                    <a:ext uri="{9D8B030D-6E8A-4147-A177-3AD203B41FA5}">
+                      <a16:colId xmlns:a16="http://schemas.microsoft.com/office/drawing/2014/main" val="3018230090"/>
+                    </a:ext>
+                  </a:extLst>
+                </a:gridCol>
+                <a:gridCol w="5545123">
+                  <a:extLst>
+                    <a:ext uri="{9D8B030D-6E8A-4147-A177-3AD203B41FA5}">
+                      <a16:colId xmlns:a16="http://schemas.microsoft.com/office/drawing/2014/main" val="607139208"/>
+                    </a:ext>
+                  </a:extLst>
+                </a:gridCol>
+              </a:tblGrid>
+              <a:tr h="1449380">
+                <a:tc>
+                  <a:txBody>
+                    <a:bodyPr/>
+                    <a:lstStyle/>
+                    <a:p>
+                      <a:pPr algn="ctr" rtl="0" fontAlgn="b">
+                        <a:buNone/>
+                      </a:pPr>
+                      <a:r>
+                        <a:rPr lang="es-CO" sz="1600" b="1" dirty="0">
+                          <a:effectLst/>
+                          <a:latin typeface="Arial" panose="020B0604020202020204" pitchFamily="34" charset="0"/>
+                        </a:rPr>
+                        <a:t>identificador(ID) de la historia</a:t>
+                      </a:r>
+                    </a:p>
+                  </a:txBody>
+                  <a:tcPr marL="14288" marR="14288" marT="9525" marB="9525" anchor="b"/>
+                </a:tc>
+                <a:tc>
+                  <a:txBody>
+                    <a:bodyPr/>
+                    <a:lstStyle/>
+                    <a:p>
+                      <a:pPr algn="ctr" rtl="0" fontAlgn="b">
+                        <a:buNone/>
+                      </a:pPr>
+                      <a:r>
+                        <a:rPr lang="es-CO" sz="1600" b="1" dirty="0">
+                          <a:effectLst/>
+                        </a:rPr>
+                        <a:t>desarrollador 1</a:t>
+                      </a:r>
+                      <a:endParaRPr lang="es-CO" sz="1600" b="1" dirty="0">
+                        <a:effectLst/>
+                        <a:latin typeface="Arial" panose="020B0604020202020204" pitchFamily="34" charset="0"/>
+                      </a:endParaRPr>
+                    </a:p>
+                  </a:txBody>
+                  <a:tcPr marL="14084" marR="14084" marT="9389" marB="9389" anchor="b"/>
+                </a:tc>
+                <a:tc>
+                  <a:txBody>
+                    <a:bodyPr/>
+                    <a:lstStyle/>
+                    <a:p>
+                      <a:pPr algn="ctr" rtl="0" fontAlgn="b">
+                        <a:buNone/>
+                      </a:pPr>
+                      <a:r>
+                        <a:rPr lang="es-CO" sz="1600" b="1" dirty="0">
+                          <a:effectLst/>
+                        </a:rPr>
+                        <a:t>desarrollador 2</a:t>
+                      </a:r>
+                      <a:endParaRPr lang="es-CO" sz="1600" b="1" dirty="0">
+                        <a:effectLst/>
+                        <a:latin typeface="Arial" panose="020B0604020202020204" pitchFamily="34" charset="0"/>
+                      </a:endParaRPr>
+                    </a:p>
+                  </a:txBody>
+                  <a:tcPr marL="14084" marR="14084" marT="9389" marB="9389" anchor="b"/>
+                </a:tc>
+                <a:tc>
+                  <a:txBody>
+                    <a:bodyPr/>
+                    <a:lstStyle/>
+                    <a:p>
+                      <a:pPr algn="ctr" rtl="0" fontAlgn="b">
+                        <a:buNone/>
+                      </a:pPr>
+                      <a:r>
+                        <a:rPr lang="es-CO" sz="1600" b="1" dirty="0" err="1">
+                          <a:effectLst/>
+                        </a:rPr>
+                        <a:t>tester</a:t>
+                      </a:r>
+                      <a:endParaRPr lang="es-CO" sz="1600" b="1" dirty="0">
+                        <a:effectLst/>
+                        <a:latin typeface="Arial" panose="020B0604020202020204" pitchFamily="34" charset="0"/>
+                      </a:endParaRPr>
+                    </a:p>
+                  </a:txBody>
+                  <a:tcPr marL="14084" marR="14084" marT="9389" marB="9389" anchor="b"/>
+                </a:tc>
+                <a:tc>
+                  <a:txBody>
+                    <a:bodyPr/>
+                    <a:lstStyle/>
+                    <a:p>
+                      <a:pPr algn="ctr" rtl="0" fontAlgn="b">
+                        <a:buNone/>
+                      </a:pPr>
+                      <a:r>
+                        <a:rPr lang="es-CO" sz="1600" b="1" dirty="0">
+                          <a:effectLst/>
+                        </a:rPr>
+                        <a:t>analista</a:t>
+                      </a:r>
+                      <a:endParaRPr lang="es-CO" sz="1600" b="1" dirty="0">
+                        <a:effectLst/>
+                        <a:latin typeface="Arial" panose="020B0604020202020204" pitchFamily="34" charset="0"/>
+                      </a:endParaRPr>
+                    </a:p>
+                  </a:txBody>
+                  <a:tcPr marL="14084" marR="14084" marT="9389" marB="9389" anchor="b"/>
+                </a:tc>
+                <a:tc>
+                  <a:txBody>
+                    <a:bodyPr/>
+                    <a:lstStyle/>
+                    <a:p>
+                      <a:pPr algn="ctr" rtl="0" fontAlgn="b">
+                        <a:buNone/>
+                      </a:pPr>
+                      <a:r>
+                        <a:rPr lang="es-CO" sz="1600" b="1" dirty="0">
+                          <a:effectLst/>
+                        </a:rPr>
+                        <a:t>promedio estimación póker </a:t>
+                      </a:r>
+                      <a:endParaRPr lang="es-CO" sz="1600" b="1" dirty="0">
+                        <a:effectLst/>
+                        <a:latin typeface="Arial" panose="020B0604020202020204" pitchFamily="34" charset="0"/>
+                      </a:endParaRPr>
+                    </a:p>
+                  </a:txBody>
+                  <a:tcPr marL="14084" marR="14084" marT="9389" marB="9389" anchor="b"/>
+                </a:tc>
+                <a:tc>
+                  <a:txBody>
+                    <a:bodyPr/>
+                    <a:lstStyle/>
+                    <a:p>
+                      <a:pPr algn="ctr" rtl="0" fontAlgn="b">
+                        <a:buNone/>
+                      </a:pPr>
+                      <a:r>
+                        <a:rPr lang="es-CO" sz="1600" b="1" dirty="0">
+                          <a:effectLst/>
+                        </a:rPr>
+                        <a:t>justificación</a:t>
+                      </a:r>
+                      <a:endParaRPr lang="es-CO" sz="1600" b="1" dirty="0">
+                        <a:effectLst/>
+                        <a:latin typeface="Arial" panose="020B0604020202020204" pitchFamily="34" charset="0"/>
+                      </a:endParaRPr>
+                    </a:p>
+                  </a:txBody>
+                  <a:tcPr marL="14084" marR="14084" marT="9389" marB="9389" anchor="b"/>
+                </a:tc>
+                <a:extLst>
+                  <a:ext uri="{0D108BD9-81ED-4DB2-BD59-A6C34878D82A}">
+                    <a16:rowId xmlns:a16="http://schemas.microsoft.com/office/drawing/2014/main" val="463076823"/>
+                  </a:ext>
+                </a:extLst>
+              </a:tr>
+              <a:tr h="985314">
+                <a:tc>
+                  <a:txBody>
+                    <a:bodyPr/>
+                    <a:lstStyle/>
+                    <a:p>
+                      <a:pPr rtl="0" fontAlgn="b">
+                        <a:buNone/>
+                      </a:pPr>
+                      <a:r>
+                        <a:rPr lang="es-CO" sz="1600">
+                          <a:effectLst/>
+                          <a:latin typeface="Arial" panose="020B0604020202020204" pitchFamily="34" charset="0"/>
+                        </a:rPr>
+                        <a:t>HE1-HU1-CA001</a:t>
+                      </a:r>
+                    </a:p>
+                  </a:txBody>
+                  <a:tcPr marL="14288" marR="14288" marT="9525" marB="9525" anchor="b"/>
+                </a:tc>
+                <a:tc>
+                  <a:txBody>
+                    <a:bodyPr/>
+                    <a:lstStyle/>
+                    <a:p>
+                      <a:pPr algn="ctr" rtl="0" fontAlgn="b">
+                        <a:buNone/>
+                      </a:pPr>
+                      <a:r>
+                        <a:rPr lang="es-CO" sz="1600" dirty="0">
+                          <a:effectLst/>
+                        </a:rPr>
+                        <a:t>2</a:t>
+                      </a:r>
+                      <a:endParaRPr lang="es-CO" sz="1600" dirty="0">
+                        <a:effectLst/>
+                        <a:latin typeface="Arial" panose="020B0604020202020204" pitchFamily="34" charset="0"/>
+                      </a:endParaRPr>
+                    </a:p>
+                  </a:txBody>
+                  <a:tcPr marL="14084" marR="14084" marT="9389" marB="9389" anchor="b"/>
+                </a:tc>
+                <a:tc>
+                  <a:txBody>
+                    <a:bodyPr/>
+                    <a:lstStyle/>
+                    <a:p>
+                      <a:pPr algn="ctr" rtl="0" fontAlgn="b">
+                        <a:buNone/>
+                      </a:pPr>
+                      <a:r>
+                        <a:rPr lang="es-CO" sz="1600" dirty="0">
+                          <a:effectLst/>
+                        </a:rPr>
+                        <a:t>8</a:t>
+                      </a:r>
+                      <a:endParaRPr lang="es-CO" sz="1600" dirty="0">
+                        <a:effectLst/>
+                        <a:latin typeface="Arial" panose="020B0604020202020204" pitchFamily="34" charset="0"/>
+                      </a:endParaRPr>
+                    </a:p>
+                  </a:txBody>
+                  <a:tcPr marL="14084" marR="14084" marT="9389" marB="9389" anchor="b"/>
+                </a:tc>
+                <a:tc>
+                  <a:txBody>
+                    <a:bodyPr/>
+                    <a:lstStyle/>
+                    <a:p>
+                      <a:pPr algn="ctr" rtl="0" fontAlgn="b">
+                        <a:buNone/>
+                      </a:pPr>
+                      <a:r>
+                        <a:rPr lang="es-CO" sz="1600" dirty="0">
+                          <a:effectLst/>
+                        </a:rPr>
+                        <a:t>3</a:t>
+                      </a:r>
+                      <a:endParaRPr lang="es-CO" sz="1600" dirty="0">
+                        <a:effectLst/>
+                        <a:latin typeface="Arial" panose="020B0604020202020204" pitchFamily="34" charset="0"/>
+                      </a:endParaRPr>
+                    </a:p>
+                  </a:txBody>
+                  <a:tcPr marL="14084" marR="14084" marT="9389" marB="9389" anchor="b"/>
+                </a:tc>
+                <a:tc>
+                  <a:txBody>
+                    <a:bodyPr/>
+                    <a:lstStyle/>
+                    <a:p>
+                      <a:pPr algn="ctr" rtl="0" fontAlgn="b">
+                        <a:buNone/>
+                      </a:pPr>
+                      <a:r>
+                        <a:rPr lang="es-CO" sz="1600" dirty="0">
+                          <a:effectLst/>
+                        </a:rPr>
+                        <a:t>13</a:t>
+                      </a:r>
+                      <a:endParaRPr lang="es-CO" sz="1600" dirty="0">
+                        <a:effectLst/>
+                        <a:latin typeface="Arial" panose="020B0604020202020204" pitchFamily="34" charset="0"/>
+                      </a:endParaRPr>
+                    </a:p>
+                  </a:txBody>
+                  <a:tcPr marL="14084" marR="14084" marT="9389" marB="9389" anchor="b"/>
+                </a:tc>
+                <a:tc>
+                  <a:txBody>
+                    <a:bodyPr/>
+                    <a:lstStyle/>
+                    <a:p>
+                      <a:pPr algn="ctr" rtl="0" fontAlgn="b">
+                        <a:buNone/>
+                      </a:pPr>
+                      <a:r>
+                        <a:rPr lang="es-CO" sz="1600">
+                          <a:effectLst/>
+                        </a:rPr>
+                        <a:t>6,5</a:t>
+                      </a:r>
+                      <a:endParaRPr lang="es-CO" sz="1600">
+                        <a:effectLst/>
+                        <a:latin typeface="Arial" panose="020B0604020202020204" pitchFamily="34" charset="0"/>
+                      </a:endParaRPr>
+                    </a:p>
+                  </a:txBody>
+                  <a:tcPr marL="14084" marR="14084" marT="9389" marB="9389" anchor="b"/>
+                </a:tc>
+                <a:tc>
+                  <a:txBody>
+                    <a:bodyPr/>
+                    <a:lstStyle/>
+                    <a:p>
+                      <a:pPr rtl="0" fontAlgn="b">
+                        <a:buNone/>
+                      </a:pPr>
+                      <a:r>
+                        <a:rPr lang="es-CO" sz="1600">
+                          <a:effectLst/>
+                        </a:rPr>
+                        <a:t>Requiere la lógica para subir y optimizar multimedia (imágenes de joyas/perfumes), validación de campos obligatorios e integración con la base de datos de inventario.</a:t>
+                      </a:r>
+                      <a:endParaRPr lang="es-CO" sz="1600">
+                        <a:effectLst/>
+                        <a:latin typeface="Arial" panose="020B0604020202020204" pitchFamily="34" charset="0"/>
+                      </a:endParaRPr>
+                    </a:p>
+                  </a:txBody>
+                  <a:tcPr marL="14084" marR="14084" marT="9389" marB="9389" anchor="b"/>
+                </a:tc>
+                <a:extLst>
+                  <a:ext uri="{0D108BD9-81ED-4DB2-BD59-A6C34878D82A}">
+                    <a16:rowId xmlns:a16="http://schemas.microsoft.com/office/drawing/2014/main" val="2850648851"/>
+                  </a:ext>
+                </a:extLst>
+              </a:tr>
+              <a:tr h="985314">
+                <a:tc>
+                  <a:txBody>
+                    <a:bodyPr/>
+                    <a:lstStyle/>
+                    <a:p>
+                      <a:pPr rtl="0" fontAlgn="b">
+                        <a:buNone/>
+                      </a:pPr>
+                      <a:r>
+                        <a:rPr lang="es-CO" sz="1600" dirty="0">
+                          <a:effectLst/>
+                          <a:latin typeface="Arial" panose="020B0604020202020204" pitchFamily="34" charset="0"/>
+                        </a:rPr>
+                        <a:t>HE1-HU2-CA002</a:t>
+                      </a:r>
+                    </a:p>
+                  </a:txBody>
+                  <a:tcPr marL="14288" marR="14288" marT="9525" marB="9525" anchor="b"/>
+                </a:tc>
+                <a:tc>
+                  <a:txBody>
+                    <a:bodyPr/>
+                    <a:lstStyle/>
+                    <a:p>
+                      <a:pPr algn="ctr" rtl="0" fontAlgn="b">
+                        <a:buNone/>
+                      </a:pPr>
+                      <a:r>
+                        <a:rPr lang="es-CO" sz="1600" dirty="0">
+                          <a:effectLst/>
+                        </a:rPr>
+                        <a:t>3</a:t>
+                      </a:r>
+                      <a:endParaRPr lang="es-CO" sz="1600" dirty="0">
+                        <a:effectLst/>
+                        <a:latin typeface="Arial" panose="020B0604020202020204" pitchFamily="34" charset="0"/>
+                      </a:endParaRPr>
+                    </a:p>
+                  </a:txBody>
+                  <a:tcPr marL="14084" marR="14084" marT="9389" marB="9389" anchor="b"/>
+                </a:tc>
+                <a:tc>
+                  <a:txBody>
+                    <a:bodyPr/>
+                    <a:lstStyle/>
+                    <a:p>
+                      <a:pPr algn="ctr" rtl="0" fontAlgn="b">
+                        <a:buNone/>
+                      </a:pPr>
+                      <a:r>
+                        <a:rPr lang="es-CO" sz="1600">
+                          <a:effectLst/>
+                        </a:rPr>
+                        <a:t>5</a:t>
+                      </a:r>
+                      <a:endParaRPr lang="es-CO" sz="1600">
+                        <a:effectLst/>
+                        <a:latin typeface="Arial" panose="020B0604020202020204" pitchFamily="34" charset="0"/>
+                      </a:endParaRPr>
+                    </a:p>
+                  </a:txBody>
+                  <a:tcPr marL="14084" marR="14084" marT="9389" marB="9389" anchor="b"/>
+                </a:tc>
+                <a:tc>
+                  <a:txBody>
+                    <a:bodyPr/>
+                    <a:lstStyle/>
+                    <a:p>
+                      <a:pPr algn="ctr" rtl="0" fontAlgn="b">
+                        <a:buNone/>
+                      </a:pPr>
+                      <a:r>
+                        <a:rPr lang="es-CO" sz="1600" dirty="0">
+                          <a:effectLst/>
+                        </a:rPr>
+                        <a:t>3</a:t>
+                      </a:r>
+                      <a:endParaRPr lang="es-CO" sz="1600" dirty="0">
+                        <a:effectLst/>
+                        <a:latin typeface="Arial" panose="020B0604020202020204" pitchFamily="34" charset="0"/>
+                      </a:endParaRPr>
+                    </a:p>
+                  </a:txBody>
+                  <a:tcPr marL="14084" marR="14084" marT="9389" marB="9389" anchor="b"/>
+                </a:tc>
+                <a:tc>
+                  <a:txBody>
+                    <a:bodyPr/>
+                    <a:lstStyle/>
+                    <a:p>
+                      <a:pPr algn="ctr" rtl="0" fontAlgn="b">
+                        <a:buNone/>
+                      </a:pPr>
+                      <a:r>
+                        <a:rPr lang="es-CO" sz="1600">
+                          <a:effectLst/>
+                        </a:rPr>
+                        <a:t>5</a:t>
+                      </a:r>
+                      <a:endParaRPr lang="es-CO" sz="1600">
+                        <a:effectLst/>
+                        <a:latin typeface="Arial" panose="020B0604020202020204" pitchFamily="34" charset="0"/>
+                      </a:endParaRPr>
+                    </a:p>
+                  </a:txBody>
+                  <a:tcPr marL="14084" marR="14084" marT="9389" marB="9389" anchor="b"/>
+                </a:tc>
+                <a:tc>
+                  <a:txBody>
+                    <a:bodyPr/>
+                    <a:lstStyle/>
+                    <a:p>
+                      <a:pPr algn="ctr" rtl="0" fontAlgn="b">
+                        <a:buNone/>
+                      </a:pPr>
+                      <a:r>
+                        <a:rPr lang="es-CO" sz="1600" dirty="0">
+                          <a:effectLst/>
+                        </a:rPr>
+                        <a:t>4</a:t>
+                      </a:r>
+                      <a:endParaRPr lang="es-CO" sz="1600" dirty="0">
+                        <a:effectLst/>
+                        <a:latin typeface="Arial" panose="020B0604020202020204" pitchFamily="34" charset="0"/>
+                      </a:endParaRPr>
+                    </a:p>
+                  </a:txBody>
+                  <a:tcPr marL="14084" marR="14084" marT="9389" marB="9389" anchor="b"/>
+                </a:tc>
+                <a:tc>
+                  <a:txBody>
+                    <a:bodyPr/>
+                    <a:lstStyle/>
+                    <a:p>
+                      <a:pPr rtl="0" fontAlgn="b">
+                        <a:buNone/>
+                      </a:pPr>
+                      <a:r>
+                        <a:rPr lang="es-CO" sz="1600" dirty="0">
+                          <a:effectLst/>
+                        </a:rPr>
+                        <a:t>Es un mantenimiento CRUD directo. Presenta menor complejidad que el alta, pero exige validar persistencia, consistencia de datos y actualización en tiempo real del catálogo.</a:t>
+                      </a:r>
+                      <a:endParaRPr lang="es-CO" sz="1600" dirty="0">
+                        <a:effectLst/>
+                        <a:latin typeface="Arial" panose="020B0604020202020204" pitchFamily="34" charset="0"/>
+                      </a:endParaRPr>
+                    </a:p>
+                  </a:txBody>
+                  <a:tcPr marL="14084" marR="14084" marT="9389" marB="9389" anchor="b"/>
+                </a:tc>
+                <a:extLst>
+                  <a:ext uri="{0D108BD9-81ED-4DB2-BD59-A6C34878D82A}">
+                    <a16:rowId xmlns:a16="http://schemas.microsoft.com/office/drawing/2014/main" val="2991887951"/>
+                  </a:ext>
+                </a:extLst>
+              </a:tr>
+              <a:tr h="1142636">
+                <a:tc>
+                  <a:txBody>
+                    <a:bodyPr/>
+                    <a:lstStyle/>
+                    <a:p>
+                      <a:pPr marL="0" marR="0" lvl="0" indent="0" algn="l" defTabSz="914400" rtl="0" eaLnBrk="1" fontAlgn="b" latinLnBrk="0" hangingPunct="1">
+                        <a:lnSpc>
+                          <a:spcPct val="100000"/>
+                        </a:lnSpc>
+                        <a:spcBef>
+                          <a:spcPts val="0"/>
+                        </a:spcBef>
+                        <a:spcAft>
+                          <a:spcPts val="0"/>
+                        </a:spcAft>
+                        <a:buClrTx/>
+                        <a:buSzTx/>
+                        <a:buFontTx/>
+                        <a:buNone/>
+                        <a:tabLst/>
+                        <a:defRPr/>
+                      </a:pPr>
+                      <a:r>
+                        <a:rPr lang="es-CO" sz="1600" dirty="0">
+                          <a:effectLst/>
+                          <a:latin typeface="Arial" panose="020B0604020202020204" pitchFamily="34" charset="0"/>
+                        </a:rPr>
+                        <a:t>HE1-HU3-CA003</a:t>
+                      </a:r>
+                    </a:p>
+                    <a:p>
+                      <a:pPr rtl="0" fontAlgn="b">
+                        <a:buNone/>
+                      </a:pPr>
+                      <a:endParaRPr lang="es-CO" sz="1600" dirty="0">
+                        <a:effectLst/>
+                        <a:latin typeface="Arial" panose="020B0604020202020204" pitchFamily="34" charset="0"/>
+                      </a:endParaRPr>
+                    </a:p>
+                  </a:txBody>
+                  <a:tcPr marL="14288" marR="14288" marT="9525" marB="9525" anchor="b"/>
+                </a:tc>
+                <a:tc>
+                  <a:txBody>
+                    <a:bodyPr/>
+                    <a:lstStyle/>
+                    <a:p>
+                      <a:pPr algn="ctr" rtl="0" fontAlgn="b">
+                        <a:buNone/>
+                      </a:pPr>
+                      <a:r>
+                        <a:rPr lang="es-CO" sz="1600" dirty="0">
+                          <a:effectLst/>
+                        </a:rPr>
+                        <a:t>2</a:t>
+                      </a:r>
+                      <a:endParaRPr lang="es-CO" sz="1600" dirty="0">
+                        <a:effectLst/>
+                        <a:latin typeface="Arial" panose="020B0604020202020204" pitchFamily="34" charset="0"/>
+                      </a:endParaRPr>
+                    </a:p>
+                  </a:txBody>
+                  <a:tcPr marL="14084" marR="14084" marT="9389" marB="9389" anchor="b"/>
+                </a:tc>
+                <a:tc>
+                  <a:txBody>
+                    <a:bodyPr/>
+                    <a:lstStyle/>
+                    <a:p>
+                      <a:pPr algn="ctr" rtl="0" fontAlgn="b">
+                        <a:buNone/>
+                      </a:pPr>
+                      <a:r>
+                        <a:rPr lang="es-CO" sz="1600">
+                          <a:effectLst/>
+                        </a:rPr>
+                        <a:t>20</a:t>
+                      </a:r>
+                      <a:endParaRPr lang="es-CO" sz="1600">
+                        <a:effectLst/>
+                        <a:latin typeface="Arial" panose="020B0604020202020204" pitchFamily="34" charset="0"/>
+                      </a:endParaRPr>
+                    </a:p>
+                  </a:txBody>
+                  <a:tcPr marL="14084" marR="14084" marT="9389" marB="9389" anchor="b"/>
+                </a:tc>
+                <a:tc>
+                  <a:txBody>
+                    <a:bodyPr/>
+                    <a:lstStyle/>
+                    <a:p>
+                      <a:pPr algn="ctr" rtl="0" fontAlgn="b">
+                        <a:buNone/>
+                      </a:pPr>
+                      <a:r>
+                        <a:rPr lang="es-CO" sz="1600" dirty="0">
+                          <a:effectLst/>
+                        </a:rPr>
+                        <a:t>3</a:t>
+                      </a:r>
+                      <a:endParaRPr lang="es-CO" sz="1600" dirty="0">
+                        <a:effectLst/>
+                        <a:latin typeface="Arial" panose="020B0604020202020204" pitchFamily="34" charset="0"/>
+                      </a:endParaRPr>
+                    </a:p>
+                  </a:txBody>
+                  <a:tcPr marL="14084" marR="14084" marT="9389" marB="9389" anchor="b"/>
+                </a:tc>
+                <a:tc>
+                  <a:txBody>
+                    <a:bodyPr/>
+                    <a:lstStyle/>
+                    <a:p>
+                      <a:pPr algn="ctr" rtl="0" fontAlgn="b">
+                        <a:buNone/>
+                      </a:pPr>
+                      <a:r>
+                        <a:rPr lang="es-CO" sz="1600">
+                          <a:effectLst/>
+                        </a:rPr>
+                        <a:t>100</a:t>
+                      </a:r>
+                      <a:endParaRPr lang="es-CO" sz="1600">
+                        <a:effectLst/>
+                        <a:latin typeface="Arial" panose="020B0604020202020204" pitchFamily="34" charset="0"/>
+                      </a:endParaRPr>
+                    </a:p>
+                  </a:txBody>
+                  <a:tcPr marL="14084" marR="14084" marT="9389" marB="9389" anchor="b"/>
+                </a:tc>
+                <a:tc>
+                  <a:txBody>
+                    <a:bodyPr/>
+                    <a:lstStyle/>
+                    <a:p>
+                      <a:pPr algn="ctr" rtl="0" fontAlgn="b">
+                        <a:buNone/>
+                      </a:pPr>
+                      <a:r>
+                        <a:rPr lang="es-CO" sz="1600">
+                          <a:effectLst/>
+                        </a:rPr>
+                        <a:t>31,25</a:t>
+                      </a:r>
+                      <a:endParaRPr lang="es-CO" sz="1600">
+                        <a:effectLst/>
+                        <a:latin typeface="Arial" panose="020B0604020202020204" pitchFamily="34" charset="0"/>
+                      </a:endParaRPr>
+                    </a:p>
+                  </a:txBody>
+                  <a:tcPr marL="14084" marR="14084" marT="9389" marB="9389" anchor="b"/>
+                </a:tc>
+                <a:tc>
+                  <a:txBody>
+                    <a:bodyPr/>
+                    <a:lstStyle/>
+                    <a:p>
+                      <a:pPr rtl="0" fontAlgn="b">
+                        <a:buNone/>
+                      </a:pPr>
+                      <a:r>
+                        <a:rPr lang="es-CO" sz="1600" dirty="0">
+                          <a:effectLst/>
+                        </a:rPr>
+                        <a:t>Es una de las tareas más complejas. Exige diseño visual atractivo, optimización de carga diferida para imágenes de alta calidad, filtros dinámicos, paginación y alta concurrencia de clientes.</a:t>
+                      </a:r>
+                      <a:endParaRPr lang="es-CO" sz="1600" dirty="0">
+                        <a:effectLst/>
+                        <a:latin typeface="Arial" panose="020B0604020202020204" pitchFamily="34" charset="0"/>
+                      </a:endParaRPr>
+                    </a:p>
+                  </a:txBody>
+                  <a:tcPr marL="14084" marR="14084" marT="9389" marB="9389" anchor="b"/>
+                </a:tc>
+                <a:extLst>
+                  <a:ext uri="{0D108BD9-81ED-4DB2-BD59-A6C34878D82A}">
+                    <a16:rowId xmlns:a16="http://schemas.microsoft.com/office/drawing/2014/main" val="1712092229"/>
+                  </a:ext>
+                </a:extLst>
+              </a:tr>
+            </a:tbl>
+          </a:graphicData>
+        </a:graphic>
+      </p:graphicFrame>
+    </p:spTree>
+    <p:extLst>
+      <p:ext uri="{BB962C8B-B14F-4D97-AF65-F5344CB8AC3E}">
+        <p14:creationId xmlns:p14="http://schemas.microsoft.com/office/powerpoint/2010/main" val="550869811"/>
+      </p:ext>
+    </p:extLst>
+  </p:cSld>
+  <p:clrMapOvr>
+    <a:masterClrMapping/>
+  </p:clrMapOvr>
+</p:sld>
+</file>
+
+<file path=ppt/slides/slide9.xml><?xml version="1.0" encoding="utf-8"?>
+<p:sld xmlns:a="http://schemas.openxmlformats.org/drawingml/2006/main" xmlns:r="http://schemas.openxmlformats.org/officeDocument/2006/relationships" xmlns:p="http://schemas.openxmlformats.org/presentationml/2006/main">
+  <p:cSld>
+    <p:bg>
+      <p:bgPr>
+        <a:solidFill>
+          <a:schemeClr val="bg1"/>
+        </a:solidFill>
+        <a:effectLst/>
+      </p:bgPr>
+    </p:bg>
+    <p:spTree>
+      <p:nvGrpSpPr>
+        <p:cNvPr id="1" name=""/>
+        <p:cNvGrpSpPr/>
+        <p:nvPr/>
+      </p:nvGrpSpPr>
+      <p:grpSpPr>
+        <a:xfrm>
+          <a:off x="0" y="0"/>
+          <a:ext cx="0" cy="0"/>
+          <a:chOff x="0" y="0"/>
+          <a:chExt cx="0" cy="0"/>
+        </a:xfrm>
+      </p:grpSpPr>
+      <p:sp>
+        <p:nvSpPr>
+          <p:cNvPr id="10" name="Down Arrow 7">
+            <a:extLst>
+              <a:ext uri="{FF2B5EF4-FFF2-40B4-BE49-F238E27FC236}">
+                <a16:creationId xmlns:a16="http://schemas.microsoft.com/office/drawing/2014/main" id="{D4771268-CB57-404A-9271-370EB28F6090}"/>
+              </a:ext>
+              <a:ext uri="{C183D7F6-B498-43B3-948B-1728B52AA6E4}">
+                <adec:decorative xmlns:adec="http://schemas.microsoft.com/office/drawing/2017/decorative" val="1"/>
+              </a:ext>
+            </a:extLst>
+          </p:cNvPr>
+          <p:cNvSpPr>
+            <a:spLocks noGrp="1" noRot="1" noChangeAspect="1" noMove="1" noResize="1" noEditPoints="1" noAdjustHandles="1" noChangeArrowheads="1" noChangeShapeType="1" noTextEdit="1"/>
+          </p:cNvSpPr>
+          <p:nvPr>
+            <p:extLst>
+              <p:ext uri="{386F3935-93C4-4BCD-93E2-E3B085C9AB24}">
+                <p16:designElem xmlns:p16="http://schemas.microsoft.com/office/powerpoint/2015/main" val="1"/>
+              </p:ext>
+            </p:extLst>
+          </p:nvPr>
+        </p:nvSpPr>
+        <p:spPr>
+          <a:xfrm rot="16200000">
+            <a:off x="800100" y="1491343"/>
+            <a:ext cx="3333749" cy="3499103"/>
+          </a:xfrm>
+          <a:prstGeom prst="downArrow">
+            <a:avLst>
+              <a:gd name="adj1" fmla="val 100000"/>
+              <a:gd name="adj2" fmla="val 15788"/>
+            </a:avLst>
+          </a:prstGeom>
+          <a:solidFill>
+            <a:srgbClr val="404040"/>
+          </a:solidFill>
+          <a:ln w="53975">
+            <a:noFill/>
+          </a:ln>
+        </p:spPr>
+        <p:style>
+          <a:lnRef idx="2">
+            <a:schemeClr val="accent1">
+              <a:shade val="50000"/>
+            </a:schemeClr>
+          </a:lnRef>
+          <a:fillRef idx="1">
+            <a:schemeClr val="accent1"/>
+          </a:fillRef>
+          <a:effectRef idx="0">
+            <a:schemeClr val="accent1"/>
+          </a:effectRef>
+          <a:fontRef idx="minor">
+            <a:schemeClr val="lt1"/>
+          </a:fontRef>
+        </p:style>
+        <p:txBody>
+          <a:bodyPr rtlCol="0" anchor="ctr"/>
+          <a:lstStyle/>
+          <a:p>
+            <a:pPr algn="ctr"/>
+            <a:endParaRPr lang="en-US"/>
+          </a:p>
+        </p:txBody>
+      </p:sp>
+      <p:sp>
+        <p:nvSpPr>
+          <p:cNvPr id="2" name="Título 1">
+            <a:extLst>
+              <a:ext uri="{FF2B5EF4-FFF2-40B4-BE49-F238E27FC236}">
+                <a16:creationId xmlns:a16="http://schemas.microsoft.com/office/drawing/2014/main" id="{E7DD6360-CD78-BB3F-4627-A7ED5C9D30C5}"/>
+              </a:ext>
+            </a:extLst>
+          </p:cNvPr>
+          <p:cNvSpPr>
+            <a:spLocks noGrp="1"/>
+          </p:cNvSpPr>
+          <p:nvPr>
+            <p:ph type="title"/>
+          </p:nvPr>
+        </p:nvSpPr>
+        <p:spPr>
+          <a:xfrm>
+            <a:off x="1028700" y="1967266"/>
+            <a:ext cx="2628900" cy="2547257"/>
+          </a:xfrm>
+          <a:noFill/>
+        </p:spPr>
+        <p:txBody>
+          <a:bodyPr vert="horz" lIns="91440" tIns="45720" rIns="91440" bIns="45720" rtlCol="0" anchor="ctr">
+            <a:normAutofit/>
+          </a:bodyPr>
+          <a:lstStyle/>
+          <a:p>
+            <a:pPr algn="ctr"/>
+            <a:r>
+              <a:rPr lang="en-US" sz="3600" kern="1200">
+                <a:solidFill>
+                  <a:srgbClr val="FFFFFF"/>
+                </a:solidFill>
+                <a:latin typeface="+mj-lt"/>
+                <a:ea typeface="+mj-ea"/>
+                <a:cs typeface="+mj-cs"/>
+              </a:rPr>
+              <a:t>Story Mapping :</a:t>
+            </a:r>
+          </a:p>
+        </p:txBody>
+      </p:sp>
+      <p:pic>
+        <p:nvPicPr>
+          <p:cNvPr id="5" name="Imagen 4">
+            <a:extLst>
+              <a:ext uri="{FF2B5EF4-FFF2-40B4-BE49-F238E27FC236}">
+                <a16:creationId xmlns:a16="http://schemas.microsoft.com/office/drawing/2014/main" id="{D78A79AA-76CE-432E-6683-A2B53B046F4A}"/>
+              </a:ext>
+            </a:extLst>
+          </p:cNvPr>
+          <p:cNvPicPr>
+            <a:picLocks noChangeAspect="1"/>
+          </p:cNvPicPr>
+          <p:nvPr/>
+        </p:nvPicPr>
+        <p:blipFill>
+          <a:blip r:embed="rId2"/>
+          <a:stretch>
+            <a:fillRect/>
+          </a:stretch>
+        </p:blipFill>
+        <p:spPr>
+          <a:xfrm>
+            <a:off x="4626264" y="1168736"/>
+            <a:ext cx="7565736" cy="4520527"/>
+          </a:xfrm>
+          <a:prstGeom prst="rect">
+            <a:avLst/>
+          </a:prstGeom>
+        </p:spPr>
+      </p:pic>
+    </p:spTree>
+    <p:extLst>
+      <p:ext uri="{BB962C8B-B14F-4D97-AF65-F5344CB8AC3E}">
+        <p14:creationId xmlns:p14="http://schemas.microsoft.com/office/powerpoint/2010/main" val="4091595647"/>
       </p:ext>
     </p:extLst>
   </p:cSld>

</xml_diff>